<commit_message>
Rename "Enter my details" to "Select preferences" across landing, how-it-works, and quick-mode banner
Co-Authored-By: Claude Sonnet 5 <noreply@anthropic.com>
</commit_message>
<xml_diff>
--- a/Modfied BurnsideAILabs_FoodAccess_Presentation.pptx
+++ b/Modfied BurnsideAILabs_FoodAccess_Presentation.pptx
@@ -12,8 +12,8 @@
     <p:sldId id="270" r:id="rId3"/>
     <p:sldId id="257" r:id="rId4"/>
     <p:sldId id="258" r:id="rId5"/>
-    <p:sldId id="262" r:id="rId6"/>
-    <p:sldId id="264" r:id="rId7"/>
+    <p:sldId id="264" r:id="rId6"/>
+    <p:sldId id="262" r:id="rId7"/>
     <p:sldId id="268" r:id="rId8"/>
   </p:sldIdLst>
   <p:sldSz cx="12192000" cy="6858000"/>
@@ -2008,7 +2008,7 @@
               <a:rPr sz="1100">
                 <a:latin typeface="Liberation Sans"/>
               </a:rPr>
-              <a:t>[25s] One tap: the actual way there. Walk 3 minutes to the Park Street stop, ride the CTtransit 33 eight minutes to Parkville, walk 3 more — 14 minutes total, with tap-to-call. Distances are illustrative mockups; routing uses real CTtransit GTFS and OpenStreetMap data.</a:t>
+              <a:t>[15s] Foodshare, 211 CT, and the USDA SNAP retailer CSV feed normalization, where the LLM reconciles messy hours into our schema. Sites go into a spatial index joined with CTtransit GTFS. Today that’s a hand-curated 30-site dataset running client-side — nothing that can fail on stage. Next: an hourly refresh job and a 211/Foodshare partnership for live hours.</a:t>
             </a:r>
           </a:p>
         </p:txBody>
@@ -2081,7 +2081,7 @@
               <a:rPr sz="1100">
                 <a:latin typeface="Liberation Sans"/>
               </a:rPr>
-              <a:t>[15s] Foodshare, 211 CT, and the USDA SNAP retailer CSV feed normalization, where the LLM reconciles messy hours into our schema. Sites go into a spatial index joined with CTtransit GTFS. Today that’s a hand-curated 30-site dataset running client-side — nothing that can fail on stage. Next: an hourly refresh job and a 211/Foodshare partnership for live hours.</a:t>
+              <a:t>[25s] One tap: the actual way there. Walk 3 minutes to the Park Street stop, ride the CTtransit 33 eight minutes to Parkville, walk 3 more — 14 minutes total, with tap-to-call. Distances are illustrative mockups; routing uses real CTtransit GTFS and OpenStreetMap data.</a:t>
             </a:r>
           </a:p>
         </p:txBody>
@@ -5368,61 +5368,13 @@
       </p:sp>
       <p:sp>
         <p:nvSpPr>
-          <p:cNvPr id="8" name="TextBox 7"/>
-          <p:cNvSpPr txBox="1"/>
-          <p:nvPr/>
-        </p:nvSpPr>
-        <p:spPr>
-          <a:xfrm>
-            <a:off x="3159546" y="2646851"/>
-            <a:ext cx="7216299" cy="553998"/>
-          </a:xfrm>
-          <a:prstGeom prst="rect">
-            <a:avLst/>
-          </a:prstGeom>
-          <a:noFill/>
-        </p:spPr>
-        <p:txBody>
-          <a:bodyPr wrap="square" anchor="t">
-            <a:spAutoFit/>
-          </a:bodyPr>
-          <a:lstStyle/>
-          <a:p>
-            <a:pPr algn="l">
-              <a:spcBef>
-                <a:spcPts val="0"/>
-              </a:spcBef>
-              <a:spcAft>
-                <a:spcPts val="200"/>
-              </a:spcAft>
-            </a:pPr>
-            <a:r>
-              <a:rPr lang="en-US" sz="3000" b="0" dirty="0">
-                <a:solidFill>
-                  <a:srgbClr val="A85A38"/>
-                </a:solidFill>
-                <a:latin typeface="DejaVu Serif"/>
-              </a:rPr>
-              <a:t>Ask naturally. Get there reliably.</a:t>
-            </a:r>
-            <a:endParaRPr sz="3000" b="0" dirty="0">
-              <a:solidFill>
-                <a:srgbClr val="A85A38"/>
-              </a:solidFill>
-              <a:latin typeface="DejaVu Serif"/>
-            </a:endParaRPr>
-          </a:p>
-        </p:txBody>
-      </p:sp>
-      <p:sp>
-        <p:nvSpPr>
           <p:cNvPr id="9" name="TextBox 8"/>
           <p:cNvSpPr txBox="1"/>
           <p:nvPr/>
         </p:nvSpPr>
         <p:spPr>
           <a:xfrm>
-            <a:off x="519952" y="3563929"/>
+            <a:off x="519952" y="3102501"/>
             <a:ext cx="10515600" cy="1338828"/>
           </a:xfrm>
           <a:prstGeom prst="rect">
@@ -8114,6 +8066,50 @@
       </p:grpSpPr>
       <p:sp>
         <p:nvSpPr>
+          <p:cNvPr id="2" name="Rectangle 1"/>
+          <p:cNvSpPr/>
+          <p:nvPr/>
+        </p:nvSpPr>
+        <p:spPr>
+          <a:xfrm>
+            <a:off x="0" y="0"/>
+            <a:ext cx="12191695" cy="6858000"/>
+          </a:xfrm>
+          <a:prstGeom prst="rect">
+            <a:avLst/>
+          </a:prstGeom>
+          <a:solidFill>
+            <a:srgbClr val="FAF6EF"/>
+          </a:solidFill>
+          <a:ln>
+            <a:noFill/>
+          </a:ln>
+        </p:spPr>
+        <p:style>
+          <a:lnRef idx="1">
+            <a:schemeClr val="accent1"/>
+          </a:lnRef>
+          <a:fillRef idx="3">
+            <a:schemeClr val="accent1"/>
+          </a:fillRef>
+          <a:effectRef idx="2">
+            <a:schemeClr val="accent1"/>
+          </a:effectRef>
+          <a:fontRef idx="minor">
+            <a:schemeClr val="lt1"/>
+          </a:fontRef>
+        </p:style>
+        <p:txBody>
+          <a:bodyPr rtlCol="0" anchor="ctr"/>
+          <a:lstStyle/>
+          <a:p>
+            <a:pPr algn="ctr"/>
+            <a:endParaRPr/>
+          </a:p>
+        </p:txBody>
+      </p:sp>
+      <p:sp>
+        <p:nvSpPr>
           <p:cNvPr id="3" name="Rounded Rectangle 2"/>
           <p:cNvSpPr/>
           <p:nvPr/>
@@ -8166,8 +8162,8 @@
         </p:nvSpPr>
         <p:spPr>
           <a:xfrm>
-            <a:off x="548640" y="310896"/>
-            <a:ext cx="3108960" cy="310896"/>
+            <a:off x="548640" y="339386"/>
+            <a:ext cx="3108960" cy="253916"/>
           </a:xfrm>
           <a:prstGeom prst="rect">
             <a:avLst/>
@@ -8189,13 +8185,13 @@
               </a:spcAft>
             </a:pPr>
             <a:r>
-              <a:rPr sz="1050" b="1">
+              <a:rPr sz="1050" b="1" dirty="0">
                 <a:solidFill>
                   <a:srgbClr val="FFFFFF"/>
                 </a:solidFill>
                 <a:latin typeface="Liberation Sans"/>
               </a:rPr>
-              <a:t>DEMO  ·  25 SECONDS</a:t>
+              <a:t>DATA PIPELINE </a:t>
             </a:r>
           </a:p>
         </p:txBody>
@@ -8209,7 +8205,7 @@
         <p:spPr>
           <a:xfrm>
             <a:off x="548640" y="749808"/>
-            <a:ext cx="11064240" cy="615553"/>
+            <a:ext cx="11064240" cy="1164421"/>
           </a:xfrm>
           <a:prstGeom prst="rect">
             <a:avLst/>
@@ -8222,10 +8218,7 @@
           </a:bodyPr>
           <a:lstStyle/>
           <a:p>
-            <a:pPr algn="l">
-              <a:spcBef>
-                <a:spcPts val="0"/>
-              </a:spcBef>
+            <a:pPr>
               <a:spcAft>
                 <a:spcPts val="200"/>
               </a:spcAft>
@@ -8237,7 +8230,23 @@
                 </a:solidFill>
                 <a:latin typeface="DejaVu Serif"/>
               </a:rPr>
-              <a:t>Our solution</a:t>
+              <a:t>AI where it matters: </a:t>
+            </a:r>
+          </a:p>
+          <a:p>
+            <a:pPr>
+              <a:spcAft>
+                <a:spcPts val="200"/>
+              </a:spcAft>
+            </a:pPr>
+            <a:r>
+              <a:rPr lang="en-US" sz="3400" b="1" dirty="0">
+                <a:solidFill>
+                  <a:srgbClr val="2E2A26"/>
+                </a:solidFill>
+                <a:latin typeface="DejaVu Serif"/>
+              </a:rPr>
+              <a:t>	Fresh data daily</a:t>
             </a:r>
             <a:endParaRPr sz="3400" b="1" dirty="0">
               <a:solidFill>
@@ -8250,17 +8259,67 @@
       </p:sp>
       <p:sp>
         <p:nvSpPr>
-          <p:cNvPr id="6" name="Rectangle 5"/>
+          <p:cNvPr id="8" name="Rounded Rectangle 7"/>
           <p:cNvSpPr/>
           <p:nvPr/>
         </p:nvSpPr>
         <p:spPr>
           <a:xfrm>
-            <a:off x="548640" y="1481328"/>
-            <a:ext cx="1280160" cy="50800"/>
-          </a:xfrm>
-          <a:prstGeom prst="rect">
-            <a:avLst/>
+            <a:off x="548640" y="2103120"/>
+            <a:ext cx="1874519" cy="1828800"/>
+          </a:xfrm>
+          <a:prstGeom prst="roundRect">
+            <a:avLst>
+              <a:gd name="adj" fmla="val 10000"/>
+            </a:avLst>
+          </a:prstGeom>
+          <a:solidFill>
+            <a:srgbClr val="FFFFFF"/>
+          </a:solidFill>
+          <a:ln w="15875">
+            <a:solidFill>
+              <a:srgbClr val="E2D7C2"/>
+            </a:solidFill>
+          </a:ln>
+        </p:spPr>
+        <p:style>
+          <a:lnRef idx="1">
+            <a:schemeClr val="accent1"/>
+          </a:lnRef>
+          <a:fillRef idx="3">
+            <a:schemeClr val="accent1"/>
+          </a:fillRef>
+          <a:effectRef idx="2">
+            <a:schemeClr val="accent1"/>
+          </a:effectRef>
+          <a:fontRef idx="minor">
+            <a:schemeClr val="lt1"/>
+          </a:fontRef>
+        </p:style>
+        <p:txBody>
+          <a:bodyPr rtlCol="0" anchor="ctr"/>
+          <a:lstStyle/>
+          <a:p>
+            <a:pPr algn="ctr"/>
+            <a:endParaRPr/>
+          </a:p>
+        </p:txBody>
+      </p:sp>
+      <p:sp>
+        <p:nvSpPr>
+          <p:cNvPr id="9" name="Rounded Rectangle 8"/>
+          <p:cNvSpPr/>
+          <p:nvPr/>
+        </p:nvSpPr>
+        <p:spPr>
+          <a:xfrm>
+            <a:off x="548640" y="2103120"/>
+            <a:ext cx="1874519" cy="114300"/>
+          </a:xfrm>
+          <a:prstGeom prst="roundRect">
+            <a:avLst>
+              <a:gd name="adj" fmla="val 50000"/>
+            </a:avLst>
           </a:prstGeom>
           <a:solidFill>
             <a:srgbClr val="C96F4A"/>
@@ -8294,102 +8353,14 @@
       </p:sp>
       <p:sp>
         <p:nvSpPr>
-          <p:cNvPr id="18" name="Rectangle 17"/>
-          <p:cNvSpPr/>
-          <p:nvPr/>
-        </p:nvSpPr>
-        <p:spPr>
-          <a:xfrm>
-            <a:off x="685800" y="6720840"/>
-            <a:ext cx="7132320" cy="38100"/>
-          </a:xfrm>
-          <a:prstGeom prst="rect">
-            <a:avLst/>
-          </a:prstGeom>
-          <a:solidFill>
-            <a:srgbClr val="E2D7C2"/>
-          </a:solidFill>
-          <a:ln>
-            <a:noFill/>
-          </a:ln>
-        </p:spPr>
-        <p:style>
-          <a:lnRef idx="1">
-            <a:schemeClr val="accent1"/>
-          </a:lnRef>
-          <a:fillRef idx="3">
-            <a:schemeClr val="accent1"/>
-          </a:fillRef>
-          <a:effectRef idx="2">
-            <a:schemeClr val="accent1"/>
-          </a:effectRef>
-          <a:fontRef idx="minor">
-            <a:schemeClr val="lt1"/>
-          </a:fontRef>
-        </p:style>
-        <p:txBody>
-          <a:bodyPr rtlCol="0" anchor="ctr"/>
-          <a:lstStyle/>
-          <a:p>
-            <a:pPr algn="ctr"/>
-            <a:endParaRPr/>
-          </a:p>
-        </p:txBody>
-      </p:sp>
-      <p:sp>
-        <p:nvSpPr>
-          <p:cNvPr id="19" name="Rectangle 18"/>
-          <p:cNvSpPr/>
-          <p:nvPr/>
-        </p:nvSpPr>
-        <p:spPr>
-          <a:xfrm>
-            <a:off x="685800" y="7543800"/>
-            <a:ext cx="7132320" cy="38100"/>
-          </a:xfrm>
-          <a:prstGeom prst="rect">
-            <a:avLst/>
-          </a:prstGeom>
-          <a:solidFill>
-            <a:srgbClr val="E2D7C2"/>
-          </a:solidFill>
-          <a:ln>
-            <a:noFill/>
-          </a:ln>
-        </p:spPr>
-        <p:style>
-          <a:lnRef idx="1">
-            <a:schemeClr val="accent1"/>
-          </a:lnRef>
-          <a:fillRef idx="3">
-            <a:schemeClr val="accent1"/>
-          </a:fillRef>
-          <a:effectRef idx="2">
-            <a:schemeClr val="accent1"/>
-          </a:effectRef>
-          <a:fontRef idx="minor">
-            <a:schemeClr val="lt1"/>
-          </a:fontRef>
-        </p:style>
-        <p:txBody>
-          <a:bodyPr rtlCol="0" anchor="ctr"/>
-          <a:lstStyle/>
-          <a:p>
-            <a:pPr algn="ctr"/>
-            <a:endParaRPr/>
-          </a:p>
-        </p:txBody>
-      </p:sp>
-      <p:sp>
-        <p:nvSpPr>
-          <p:cNvPr id="44" name="TextBox 43"/>
+          <p:cNvPr id="10" name="TextBox 9"/>
           <p:cNvSpPr txBox="1"/>
           <p:nvPr/>
         </p:nvSpPr>
         <p:spPr>
           <a:xfrm>
-            <a:off x="9006840" y="3566160"/>
-            <a:ext cx="2377440" cy="365760"/>
+            <a:off x="685800" y="2286000"/>
+            <a:ext cx="1600199" cy="365760"/>
           </a:xfrm>
           <a:prstGeom prst="rect">
             <a:avLst/>
@@ -8398,90 +8369,6 @@
         </p:spPr>
         <p:txBody>
           <a:bodyPr wrap="square" anchor="t">
-            <a:spAutoFit/>
-          </a:bodyPr>
-          <a:lstStyle/>
-          <a:p>
-            <a:pPr algn="l">
-              <a:spcBef>
-                <a:spcPts val="0"/>
-              </a:spcBef>
-              <a:spcAft>
-                <a:spcPts val="200"/>
-              </a:spcAft>
-            </a:pPr>
-            <a:r>
-              <a:rPr sz="1400" b="1">
-                <a:solidFill>
-                  <a:srgbClr val="FFFFFF"/>
-                </a:solidFill>
-                <a:latin typeface="Liberation Sans"/>
-              </a:rPr>
-              <a:t>Bus 33</a:t>
-            </a:r>
-          </a:p>
-        </p:txBody>
-      </p:sp>
-      <p:sp>
-        <p:nvSpPr>
-          <p:cNvPr id="47" name="TextBox 46"/>
-          <p:cNvSpPr txBox="1"/>
-          <p:nvPr/>
-        </p:nvSpPr>
-        <p:spPr>
-          <a:xfrm>
-            <a:off x="9006840" y="4526280"/>
-            <a:ext cx="2377440" cy="365760"/>
-          </a:xfrm>
-          <a:prstGeom prst="rect">
-            <a:avLst/>
-          </a:prstGeom>
-          <a:noFill/>
-        </p:spPr>
-        <p:txBody>
-          <a:bodyPr wrap="square" anchor="t">
-            <a:spAutoFit/>
-          </a:bodyPr>
-          <a:lstStyle/>
-          <a:p>
-            <a:pPr algn="l">
-              <a:spcBef>
-                <a:spcPts val="0"/>
-              </a:spcBef>
-              <a:spcAft>
-                <a:spcPts val="200"/>
-              </a:spcAft>
-            </a:pPr>
-            <a:r>
-              <a:rPr sz="1400" b="1">
-                <a:solidFill>
-                  <a:srgbClr val="FFFFFF"/>
-                </a:solidFill>
-                <a:latin typeface="Liberation Sans"/>
-              </a:rPr>
-              <a:t>Walk 3 min</a:t>
-            </a:r>
-          </a:p>
-        </p:txBody>
-      </p:sp>
-      <p:sp>
-        <p:nvSpPr>
-          <p:cNvPr id="50" name="TextBox 49"/>
-          <p:cNvSpPr txBox="1"/>
-          <p:nvPr/>
-        </p:nvSpPr>
-        <p:spPr>
-          <a:xfrm>
-            <a:off x="8595360" y="5636661"/>
-            <a:ext cx="2788920" cy="284693"/>
-          </a:xfrm>
-          <a:prstGeom prst="rect">
-            <a:avLst/>
-          </a:prstGeom>
-          <a:noFill/>
-        </p:spPr>
-        <p:txBody>
-          <a:bodyPr wrap="square" anchor="ctr">
             <a:spAutoFit/>
           </a:bodyPr>
           <a:lstStyle/>
@@ -8495,63 +8382,27 @@
               </a:spcAft>
             </a:pPr>
             <a:r>
-              <a:rPr sz="1250" b="1" dirty="0">
-                <a:solidFill>
-                  <a:srgbClr val="FFFFFF"/>
+              <a:rPr sz="1350" b="1">
+                <a:solidFill>
+                  <a:srgbClr val="C96F4A"/>
                 </a:solidFill>
                 <a:latin typeface="Liberation Sans"/>
               </a:rPr>
-              <a:t>TAP TOCALL  ·  (860) 728-3201</a:t>
-            </a:r>
-          </a:p>
-        </p:txBody>
-      </p:sp>
-      <p:pic>
-        <p:nvPicPr>
-          <p:cNvPr id="58" name="Picture 57">
-            <a:extLst>
-              <a:ext uri="{FF2B5EF4-FFF2-40B4-BE49-F238E27FC236}">
-                <a16:creationId xmlns:a16="http://schemas.microsoft.com/office/drawing/2014/main" id="{12353F19-6D9F-107B-E911-D6D8ADAD4A76}"/>
-              </a:ext>
-            </a:extLst>
-          </p:cNvPr>
-          <p:cNvPicPr>
-            <a:picLocks noChangeAspect="1"/>
-          </p:cNvPicPr>
-          <p:nvPr/>
-        </p:nvPicPr>
-        <p:blipFill>
-          <a:blip r:embed="rId3"/>
-          <a:stretch>
-            <a:fillRect/>
-          </a:stretch>
-        </p:blipFill>
-        <p:spPr>
-          <a:xfrm>
-            <a:off x="3733101" y="663224"/>
-            <a:ext cx="5147280" cy="5147280"/>
-          </a:xfrm>
-          <a:prstGeom prst="rect">
-            <a:avLst/>
-          </a:prstGeom>
-        </p:spPr>
-      </p:pic>
-      <p:sp>
-        <p:nvSpPr>
-          <p:cNvPr id="60" name="TextBox 59">
-            <a:extLst>
-              <a:ext uri="{FF2B5EF4-FFF2-40B4-BE49-F238E27FC236}">
-                <a16:creationId xmlns:a16="http://schemas.microsoft.com/office/drawing/2014/main" id="{50FB8D79-81AA-8647-391F-D72881F66235}"/>
-              </a:ext>
-            </a:extLst>
-          </p:cNvPr>
+              <a:t>SOURCES</a:t>
+            </a:r>
+          </a:p>
+        </p:txBody>
+      </p:sp>
+      <p:sp>
+        <p:nvSpPr>
+          <p:cNvPr id="11" name="TextBox 10"/>
           <p:cNvSpPr txBox="1"/>
           <p:nvPr/>
         </p:nvSpPr>
         <p:spPr>
           <a:xfrm>
-            <a:off x="3596641" y="5664420"/>
-            <a:ext cx="6534554" cy="584775"/>
+            <a:off x="685800" y="2788920"/>
+            <a:ext cx="1600199" cy="914400"/>
           </a:xfrm>
           <a:prstGeom prst="rect">
             <a:avLst/>
@@ -8559,14 +8410,1085 @@
           <a:noFill/>
         </p:spPr>
         <p:txBody>
+          <a:bodyPr wrap="square" anchor="t">
+            <a:spAutoFit/>
+          </a:bodyPr>
+          <a:lstStyle/>
+          <a:p>
+            <a:pPr algn="ctr">
+              <a:spcBef>
+                <a:spcPts val="0"/>
+              </a:spcBef>
+              <a:spcAft>
+                <a:spcPts val="200"/>
+              </a:spcAft>
+            </a:pPr>
+            <a:r>
+              <a:rPr sz="1250" b="0">
+                <a:solidFill>
+                  <a:srgbClr val="6E645B"/>
+                </a:solidFill>
+                <a:latin typeface="Liberation Sans"/>
+              </a:rPr>
+              <a:t>CT Foodshare
+211 CT
+USDA SNAP CSV</a:t>
+            </a:r>
+          </a:p>
+        </p:txBody>
+      </p:sp>
+      <p:cxnSp>
+        <p:nvCxnSpPr>
+          <p:cNvPr id="12" name="Connector 11"/>
+          <p:cNvCxnSpPr/>
+          <p:nvPr/>
+        </p:nvCxnSpPr>
+        <p:spPr>
+          <a:xfrm>
+            <a:off x="2496312" y="3017520"/>
+            <a:ext cx="356616" cy="0"/>
+          </a:xfrm>
+          <a:prstGeom prst="line">
+            <a:avLst/>
+          </a:prstGeom>
+          <a:ln w="38100">
+            <a:solidFill>
+              <a:srgbClr val="A85A38"/>
+            </a:solidFill>
+          </a:ln>
+        </p:spPr>
+        <p:style>
+          <a:lnRef idx="2">
+            <a:schemeClr val="accent1"/>
+          </a:lnRef>
+          <a:fillRef idx="0">
+            <a:schemeClr val="accent1"/>
+          </a:fillRef>
+          <a:effectRef idx="1">
+            <a:schemeClr val="accent1"/>
+          </a:effectRef>
+          <a:fontRef idx="minor">
+            <a:schemeClr val="tx1"/>
+          </a:fontRef>
+        </p:style>
+      </p:cxnSp>
+      <p:sp>
+        <p:nvSpPr>
+          <p:cNvPr id="14" name="Rounded Rectangle 13"/>
+          <p:cNvSpPr/>
+          <p:nvPr/>
+        </p:nvSpPr>
+        <p:spPr>
+          <a:xfrm>
+            <a:off x="2926079" y="2103120"/>
+            <a:ext cx="1874519" cy="1828800"/>
+          </a:xfrm>
+          <a:prstGeom prst="roundRect">
+            <a:avLst>
+              <a:gd name="adj" fmla="val 10000"/>
+            </a:avLst>
+          </a:prstGeom>
+          <a:solidFill>
+            <a:srgbClr val="FFFFFF"/>
+          </a:solidFill>
+          <a:ln w="15875">
+            <a:solidFill>
+              <a:srgbClr val="E2D7C2"/>
+            </a:solidFill>
+          </a:ln>
+        </p:spPr>
+        <p:style>
+          <a:lnRef idx="1">
+            <a:schemeClr val="accent1"/>
+          </a:lnRef>
+          <a:fillRef idx="3">
+            <a:schemeClr val="accent1"/>
+          </a:fillRef>
+          <a:effectRef idx="2">
+            <a:schemeClr val="accent1"/>
+          </a:effectRef>
+          <a:fontRef idx="minor">
+            <a:schemeClr val="lt1"/>
+          </a:fontRef>
+        </p:style>
+        <p:txBody>
+          <a:bodyPr rtlCol="0" anchor="ctr"/>
+          <a:lstStyle/>
+          <a:p>
+            <a:pPr algn="ctr"/>
+            <a:endParaRPr/>
+          </a:p>
+        </p:txBody>
+      </p:sp>
+      <p:sp>
+        <p:nvSpPr>
+          <p:cNvPr id="15" name="Rounded Rectangle 14"/>
+          <p:cNvSpPr/>
+          <p:nvPr/>
+        </p:nvSpPr>
+        <p:spPr>
+          <a:xfrm>
+            <a:off x="2926079" y="2103120"/>
+            <a:ext cx="1874519" cy="114300"/>
+          </a:xfrm>
+          <a:prstGeom prst="roundRect">
+            <a:avLst>
+              <a:gd name="adj" fmla="val 50000"/>
+            </a:avLst>
+          </a:prstGeom>
+          <a:solidFill>
+            <a:srgbClr val="D9A441"/>
+          </a:solidFill>
+          <a:ln>
+            <a:noFill/>
+          </a:ln>
+        </p:spPr>
+        <p:style>
+          <a:lnRef idx="1">
+            <a:schemeClr val="accent1"/>
+          </a:lnRef>
+          <a:fillRef idx="3">
+            <a:schemeClr val="accent1"/>
+          </a:fillRef>
+          <a:effectRef idx="2">
+            <a:schemeClr val="accent1"/>
+          </a:effectRef>
+          <a:fontRef idx="minor">
+            <a:schemeClr val="lt1"/>
+          </a:fontRef>
+        </p:style>
+        <p:txBody>
+          <a:bodyPr rtlCol="0" anchor="ctr"/>
+          <a:lstStyle/>
+          <a:p>
+            <a:pPr algn="ctr"/>
+            <a:endParaRPr/>
+          </a:p>
+        </p:txBody>
+      </p:sp>
+      <p:sp>
+        <p:nvSpPr>
+          <p:cNvPr id="16" name="TextBox 15"/>
+          <p:cNvSpPr txBox="1"/>
+          <p:nvPr/>
+        </p:nvSpPr>
+        <p:spPr>
+          <a:xfrm>
+            <a:off x="3063239" y="2286000"/>
+            <a:ext cx="1600199" cy="365760"/>
+          </a:xfrm>
+          <a:prstGeom prst="rect">
+            <a:avLst/>
+          </a:prstGeom>
+          <a:noFill/>
+        </p:spPr>
+        <p:txBody>
+          <a:bodyPr wrap="square" anchor="t">
+            <a:spAutoFit/>
+          </a:bodyPr>
+          <a:lstStyle/>
+          <a:p>
+            <a:pPr algn="ctr">
+              <a:spcBef>
+                <a:spcPts val="0"/>
+              </a:spcBef>
+              <a:spcAft>
+                <a:spcPts val="200"/>
+              </a:spcAft>
+            </a:pPr>
+            <a:r>
+              <a:rPr sz="1350" b="1">
+                <a:solidFill>
+                  <a:srgbClr val="D9A441"/>
+                </a:solidFill>
+                <a:latin typeface="Liberation Sans"/>
+              </a:rPr>
+              <a:t>NORMALIZE</a:t>
+            </a:r>
+          </a:p>
+        </p:txBody>
+      </p:sp>
+      <p:sp>
+        <p:nvSpPr>
+          <p:cNvPr id="17" name="TextBox 16"/>
+          <p:cNvSpPr txBox="1"/>
+          <p:nvPr/>
+        </p:nvSpPr>
+        <p:spPr>
+          <a:xfrm>
+            <a:off x="3063239" y="2788920"/>
+            <a:ext cx="1600199" cy="914400"/>
+          </a:xfrm>
+          <a:prstGeom prst="rect">
+            <a:avLst/>
+          </a:prstGeom>
+          <a:noFill/>
+        </p:spPr>
+        <p:txBody>
+          <a:bodyPr wrap="square" anchor="t">
+            <a:spAutoFit/>
+          </a:bodyPr>
+          <a:lstStyle/>
+          <a:p>
+            <a:pPr algn="ctr">
+              <a:spcBef>
+                <a:spcPts val="0"/>
+              </a:spcBef>
+              <a:spcAft>
+                <a:spcPts val="200"/>
+              </a:spcAft>
+            </a:pPr>
+            <a:r>
+              <a:rPr sz="1250" b="0">
+                <a:solidFill>
+                  <a:srgbClr val="6E645B"/>
+                </a:solidFill>
+                <a:latin typeface="Liberation Sans"/>
+              </a:rPr>
+              <a:t>LLM reconciles messy
+hours → clean schema</a:t>
+            </a:r>
+          </a:p>
+        </p:txBody>
+      </p:sp>
+      <p:cxnSp>
+        <p:nvCxnSpPr>
+          <p:cNvPr id="18" name="Connector 17"/>
+          <p:cNvCxnSpPr/>
+          <p:nvPr/>
+        </p:nvCxnSpPr>
+        <p:spPr>
+          <a:xfrm>
+            <a:off x="4873752" y="3017520"/>
+            <a:ext cx="356616" cy="0"/>
+          </a:xfrm>
+          <a:prstGeom prst="line">
+            <a:avLst/>
+          </a:prstGeom>
+          <a:ln w="38100">
+            <a:solidFill>
+              <a:srgbClr val="A85A38"/>
+            </a:solidFill>
+          </a:ln>
+        </p:spPr>
+        <p:style>
+          <a:lnRef idx="2">
+            <a:schemeClr val="accent1"/>
+          </a:lnRef>
+          <a:fillRef idx="0">
+            <a:schemeClr val="accent1"/>
+          </a:fillRef>
+          <a:effectRef idx="1">
+            <a:schemeClr val="accent1"/>
+          </a:effectRef>
+          <a:fontRef idx="minor">
+            <a:schemeClr val="tx1"/>
+          </a:fontRef>
+        </p:style>
+      </p:cxnSp>
+      <p:sp>
+        <p:nvSpPr>
+          <p:cNvPr id="20" name="Rounded Rectangle 19"/>
+          <p:cNvSpPr/>
+          <p:nvPr/>
+        </p:nvSpPr>
+        <p:spPr>
+          <a:xfrm>
+            <a:off x="5303519" y="2103120"/>
+            <a:ext cx="1874519" cy="1828800"/>
+          </a:xfrm>
+          <a:prstGeom prst="roundRect">
+            <a:avLst>
+              <a:gd name="adj" fmla="val 10000"/>
+            </a:avLst>
+          </a:prstGeom>
+          <a:solidFill>
+            <a:srgbClr val="FFFFFF"/>
+          </a:solidFill>
+          <a:ln w="15875">
+            <a:solidFill>
+              <a:srgbClr val="E2D7C2"/>
+            </a:solidFill>
+          </a:ln>
+        </p:spPr>
+        <p:style>
+          <a:lnRef idx="1">
+            <a:schemeClr val="accent1"/>
+          </a:lnRef>
+          <a:fillRef idx="3">
+            <a:schemeClr val="accent1"/>
+          </a:fillRef>
+          <a:effectRef idx="2">
+            <a:schemeClr val="accent1"/>
+          </a:effectRef>
+          <a:fontRef idx="minor">
+            <a:schemeClr val="lt1"/>
+          </a:fontRef>
+        </p:style>
+        <p:txBody>
+          <a:bodyPr rtlCol="0" anchor="ctr"/>
+          <a:lstStyle/>
+          <a:p>
+            <a:pPr algn="ctr"/>
+            <a:endParaRPr/>
+          </a:p>
+        </p:txBody>
+      </p:sp>
+      <p:sp>
+        <p:nvSpPr>
+          <p:cNvPr id="21" name="Rounded Rectangle 20"/>
+          <p:cNvSpPr/>
+          <p:nvPr/>
+        </p:nvSpPr>
+        <p:spPr>
+          <a:xfrm>
+            <a:off x="5303519" y="2103120"/>
+            <a:ext cx="1874519" cy="114300"/>
+          </a:xfrm>
+          <a:prstGeom prst="roundRect">
+            <a:avLst>
+              <a:gd name="adj" fmla="val 50000"/>
+            </a:avLst>
+          </a:prstGeom>
+          <a:solidFill>
+            <a:srgbClr val="5F7A52"/>
+          </a:solidFill>
+          <a:ln>
+            <a:noFill/>
+          </a:ln>
+        </p:spPr>
+        <p:style>
+          <a:lnRef idx="1">
+            <a:schemeClr val="accent1"/>
+          </a:lnRef>
+          <a:fillRef idx="3">
+            <a:schemeClr val="accent1"/>
+          </a:fillRef>
+          <a:effectRef idx="2">
+            <a:schemeClr val="accent1"/>
+          </a:effectRef>
+          <a:fontRef idx="minor">
+            <a:schemeClr val="lt1"/>
+          </a:fontRef>
+        </p:style>
+        <p:txBody>
+          <a:bodyPr rtlCol="0" anchor="ctr"/>
+          <a:lstStyle/>
+          <a:p>
+            <a:pPr algn="ctr"/>
+            <a:endParaRPr/>
+          </a:p>
+        </p:txBody>
+      </p:sp>
+      <p:sp>
+        <p:nvSpPr>
+          <p:cNvPr id="22" name="TextBox 21"/>
+          <p:cNvSpPr txBox="1"/>
+          <p:nvPr/>
+        </p:nvSpPr>
+        <p:spPr>
+          <a:xfrm>
+            <a:off x="5440679" y="2286000"/>
+            <a:ext cx="1600199" cy="365760"/>
+          </a:xfrm>
+          <a:prstGeom prst="rect">
+            <a:avLst/>
+          </a:prstGeom>
+          <a:noFill/>
+        </p:spPr>
+        <p:txBody>
+          <a:bodyPr wrap="square" anchor="t">
+            <a:spAutoFit/>
+          </a:bodyPr>
+          <a:lstStyle/>
+          <a:p>
+            <a:pPr algn="ctr">
+              <a:spcBef>
+                <a:spcPts val="0"/>
+              </a:spcBef>
+              <a:spcAft>
+                <a:spcPts val="200"/>
+              </a:spcAft>
+            </a:pPr>
+            <a:r>
+              <a:rPr sz="1350" b="1">
+                <a:solidFill>
+                  <a:srgbClr val="5F7A52"/>
+                </a:solidFill>
+                <a:latin typeface="Liberation Sans"/>
+              </a:rPr>
+              <a:t>INDEX</a:t>
+            </a:r>
+          </a:p>
+        </p:txBody>
+      </p:sp>
+      <p:sp>
+        <p:nvSpPr>
+          <p:cNvPr id="23" name="TextBox 22"/>
+          <p:cNvSpPr txBox="1"/>
+          <p:nvPr/>
+        </p:nvSpPr>
+        <p:spPr>
+          <a:xfrm>
+            <a:off x="5440679" y="2788920"/>
+            <a:ext cx="1600199" cy="914400"/>
+          </a:xfrm>
+          <a:prstGeom prst="rect">
+            <a:avLst/>
+          </a:prstGeom>
+          <a:noFill/>
+        </p:spPr>
+        <p:txBody>
+          <a:bodyPr wrap="square" anchor="t">
+            <a:spAutoFit/>
+          </a:bodyPr>
+          <a:lstStyle/>
+          <a:p>
+            <a:pPr algn="ctr">
+              <a:spcBef>
+                <a:spcPts val="0"/>
+              </a:spcBef>
+              <a:spcAft>
+                <a:spcPts val="200"/>
+              </a:spcAft>
+            </a:pPr>
+            <a:r>
+              <a:rPr sz="1250" b="0">
+                <a:solidFill>
+                  <a:srgbClr val="6E645B"/>
+                </a:solidFill>
+                <a:latin typeface="Liberation Sans"/>
+              </a:rPr>
+              <a:t>Spatial index
+30 Greater-Hartford sites</a:t>
+            </a:r>
+          </a:p>
+        </p:txBody>
+      </p:sp>
+      <p:cxnSp>
+        <p:nvCxnSpPr>
+          <p:cNvPr id="24" name="Connector 23"/>
+          <p:cNvCxnSpPr/>
+          <p:nvPr/>
+        </p:nvCxnSpPr>
+        <p:spPr>
+          <a:xfrm>
+            <a:off x="7251191" y="3017520"/>
+            <a:ext cx="356616" cy="0"/>
+          </a:xfrm>
+          <a:prstGeom prst="line">
+            <a:avLst/>
+          </a:prstGeom>
+          <a:ln w="38100">
+            <a:solidFill>
+              <a:srgbClr val="A85A38"/>
+            </a:solidFill>
+          </a:ln>
+        </p:spPr>
+        <p:style>
+          <a:lnRef idx="2">
+            <a:schemeClr val="accent1"/>
+          </a:lnRef>
+          <a:fillRef idx="0">
+            <a:schemeClr val="accent1"/>
+          </a:fillRef>
+          <a:effectRef idx="1">
+            <a:schemeClr val="accent1"/>
+          </a:effectRef>
+          <a:fontRef idx="minor">
+            <a:schemeClr val="tx1"/>
+          </a:fontRef>
+        </p:style>
+      </p:cxnSp>
+      <p:sp>
+        <p:nvSpPr>
+          <p:cNvPr id="26" name="Rounded Rectangle 25"/>
+          <p:cNvSpPr/>
+          <p:nvPr/>
+        </p:nvSpPr>
+        <p:spPr>
+          <a:xfrm>
+            <a:off x="7680959" y="2103120"/>
+            <a:ext cx="1874519" cy="1828800"/>
+          </a:xfrm>
+          <a:prstGeom prst="roundRect">
+            <a:avLst>
+              <a:gd name="adj" fmla="val 10000"/>
+            </a:avLst>
+          </a:prstGeom>
+          <a:solidFill>
+            <a:srgbClr val="FFFFFF"/>
+          </a:solidFill>
+          <a:ln w="15875">
+            <a:solidFill>
+              <a:srgbClr val="E2D7C2"/>
+            </a:solidFill>
+          </a:ln>
+        </p:spPr>
+        <p:style>
+          <a:lnRef idx="1">
+            <a:schemeClr val="accent1"/>
+          </a:lnRef>
+          <a:fillRef idx="3">
+            <a:schemeClr val="accent1"/>
+          </a:fillRef>
+          <a:effectRef idx="2">
+            <a:schemeClr val="accent1"/>
+          </a:effectRef>
+          <a:fontRef idx="minor">
+            <a:schemeClr val="lt1"/>
+          </a:fontRef>
+        </p:style>
+        <p:txBody>
+          <a:bodyPr rtlCol="0" anchor="ctr"/>
+          <a:lstStyle/>
+          <a:p>
+            <a:pPr algn="ctr"/>
+            <a:endParaRPr/>
+          </a:p>
+        </p:txBody>
+      </p:sp>
+      <p:sp>
+        <p:nvSpPr>
+          <p:cNvPr id="27" name="Rounded Rectangle 26"/>
+          <p:cNvSpPr/>
+          <p:nvPr/>
+        </p:nvSpPr>
+        <p:spPr>
+          <a:xfrm>
+            <a:off x="7680959" y="2103120"/>
+            <a:ext cx="1874519" cy="114300"/>
+          </a:xfrm>
+          <a:prstGeom prst="roundRect">
+            <a:avLst>
+              <a:gd name="adj" fmla="val 50000"/>
+            </a:avLst>
+          </a:prstGeom>
+          <a:solidFill>
+            <a:srgbClr val="A85A38"/>
+          </a:solidFill>
+          <a:ln>
+            <a:noFill/>
+          </a:ln>
+        </p:spPr>
+        <p:style>
+          <a:lnRef idx="1">
+            <a:schemeClr val="accent1"/>
+          </a:lnRef>
+          <a:fillRef idx="3">
+            <a:schemeClr val="accent1"/>
+          </a:fillRef>
+          <a:effectRef idx="2">
+            <a:schemeClr val="accent1"/>
+          </a:effectRef>
+          <a:fontRef idx="minor">
+            <a:schemeClr val="lt1"/>
+          </a:fontRef>
+        </p:style>
+        <p:txBody>
+          <a:bodyPr rtlCol="0" anchor="ctr"/>
+          <a:lstStyle/>
+          <a:p>
+            <a:pPr algn="ctr"/>
+            <a:endParaRPr/>
+          </a:p>
+        </p:txBody>
+      </p:sp>
+      <p:sp>
+        <p:nvSpPr>
+          <p:cNvPr id="28" name="TextBox 27"/>
+          <p:cNvSpPr txBox="1"/>
+          <p:nvPr/>
+        </p:nvSpPr>
+        <p:spPr>
+          <a:xfrm>
+            <a:off x="7818119" y="2286000"/>
+            <a:ext cx="1600199" cy="365760"/>
+          </a:xfrm>
+          <a:prstGeom prst="rect">
+            <a:avLst/>
+          </a:prstGeom>
+          <a:noFill/>
+        </p:spPr>
+        <p:txBody>
+          <a:bodyPr wrap="square" anchor="t">
+            <a:spAutoFit/>
+          </a:bodyPr>
+          <a:lstStyle/>
+          <a:p>
+            <a:pPr algn="ctr">
+              <a:spcBef>
+                <a:spcPts val="0"/>
+              </a:spcBef>
+              <a:spcAft>
+                <a:spcPts val="200"/>
+              </a:spcAft>
+            </a:pPr>
+            <a:r>
+              <a:rPr sz="1350" b="1">
+                <a:solidFill>
+                  <a:srgbClr val="A85A38"/>
+                </a:solidFill>
+                <a:latin typeface="Liberation Sans"/>
+              </a:rPr>
+              <a:t>MERGE</a:t>
+            </a:r>
+          </a:p>
+        </p:txBody>
+      </p:sp>
+      <p:sp>
+        <p:nvSpPr>
+          <p:cNvPr id="29" name="TextBox 28"/>
+          <p:cNvSpPr txBox="1"/>
+          <p:nvPr/>
+        </p:nvSpPr>
+        <p:spPr>
+          <a:xfrm>
+            <a:off x="7818119" y="2788920"/>
+            <a:ext cx="1600199" cy="914400"/>
+          </a:xfrm>
+          <a:prstGeom prst="rect">
+            <a:avLst/>
+          </a:prstGeom>
+          <a:noFill/>
+        </p:spPr>
+        <p:txBody>
+          <a:bodyPr wrap="square" anchor="t">
+            <a:spAutoFit/>
+          </a:bodyPr>
+          <a:lstStyle/>
+          <a:p>
+            <a:pPr algn="ctr">
+              <a:spcBef>
+                <a:spcPts val="0"/>
+              </a:spcBef>
+              <a:spcAft>
+                <a:spcPts val="200"/>
+              </a:spcAft>
+            </a:pPr>
+            <a:r>
+              <a:rPr sz="1250" b="0">
+                <a:solidFill>
+                  <a:srgbClr val="6E645B"/>
+                </a:solidFill>
+                <a:latin typeface="Liberation Sans"/>
+              </a:rPr>
+              <a:t>CTtransit GTFS
+stop + schedule join</a:t>
+            </a:r>
+          </a:p>
+        </p:txBody>
+      </p:sp>
+      <p:cxnSp>
+        <p:nvCxnSpPr>
+          <p:cNvPr id="30" name="Connector 29"/>
+          <p:cNvCxnSpPr/>
+          <p:nvPr/>
+        </p:nvCxnSpPr>
+        <p:spPr>
+          <a:xfrm>
+            <a:off x="9628632" y="3017520"/>
+            <a:ext cx="356616" cy="0"/>
+          </a:xfrm>
+          <a:prstGeom prst="line">
+            <a:avLst/>
+          </a:prstGeom>
+          <a:ln w="38100">
+            <a:solidFill>
+              <a:srgbClr val="A85A38"/>
+            </a:solidFill>
+          </a:ln>
+        </p:spPr>
+        <p:style>
+          <a:lnRef idx="2">
+            <a:schemeClr val="accent1"/>
+          </a:lnRef>
+          <a:fillRef idx="0">
+            <a:schemeClr val="accent1"/>
+          </a:fillRef>
+          <a:effectRef idx="1">
+            <a:schemeClr val="accent1"/>
+          </a:effectRef>
+          <a:fontRef idx="minor">
+            <a:schemeClr val="tx1"/>
+          </a:fontRef>
+        </p:style>
+      </p:cxnSp>
+      <p:sp>
+        <p:nvSpPr>
+          <p:cNvPr id="32" name="Rounded Rectangle 31"/>
+          <p:cNvSpPr/>
+          <p:nvPr/>
+        </p:nvSpPr>
+        <p:spPr>
+          <a:xfrm>
+            <a:off x="10058399" y="2103120"/>
+            <a:ext cx="1874519" cy="1828800"/>
+          </a:xfrm>
+          <a:prstGeom prst="roundRect">
+            <a:avLst>
+              <a:gd name="adj" fmla="val 10000"/>
+            </a:avLst>
+          </a:prstGeom>
+          <a:solidFill>
+            <a:srgbClr val="FFFFFF"/>
+          </a:solidFill>
+          <a:ln w="15875">
+            <a:solidFill>
+              <a:srgbClr val="E2D7C2"/>
+            </a:solidFill>
+          </a:ln>
+        </p:spPr>
+        <p:style>
+          <a:lnRef idx="1">
+            <a:schemeClr val="accent1"/>
+          </a:lnRef>
+          <a:fillRef idx="3">
+            <a:schemeClr val="accent1"/>
+          </a:fillRef>
+          <a:effectRef idx="2">
+            <a:schemeClr val="accent1"/>
+          </a:effectRef>
+          <a:fontRef idx="minor">
+            <a:schemeClr val="lt1"/>
+          </a:fontRef>
+        </p:style>
+        <p:txBody>
+          <a:bodyPr rtlCol="0" anchor="ctr"/>
+          <a:lstStyle/>
+          <a:p>
+            <a:pPr algn="ctr"/>
+            <a:endParaRPr/>
+          </a:p>
+        </p:txBody>
+      </p:sp>
+      <p:sp>
+        <p:nvSpPr>
+          <p:cNvPr id="33" name="Rounded Rectangle 32"/>
+          <p:cNvSpPr/>
+          <p:nvPr/>
+        </p:nvSpPr>
+        <p:spPr>
+          <a:xfrm>
+            <a:off x="10058399" y="2103120"/>
+            <a:ext cx="1874519" cy="114300"/>
+          </a:xfrm>
+          <a:prstGeom prst="roundRect">
+            <a:avLst>
+              <a:gd name="adj" fmla="val 50000"/>
+            </a:avLst>
+          </a:prstGeom>
+          <a:solidFill>
+            <a:srgbClr val="2E2A26"/>
+          </a:solidFill>
+          <a:ln>
+            <a:noFill/>
+          </a:ln>
+        </p:spPr>
+        <p:style>
+          <a:lnRef idx="1">
+            <a:schemeClr val="accent1"/>
+          </a:lnRef>
+          <a:fillRef idx="3">
+            <a:schemeClr val="accent1"/>
+          </a:fillRef>
+          <a:effectRef idx="2">
+            <a:schemeClr val="accent1"/>
+          </a:effectRef>
+          <a:fontRef idx="minor">
+            <a:schemeClr val="lt1"/>
+          </a:fontRef>
+        </p:style>
+        <p:txBody>
+          <a:bodyPr rtlCol="0" anchor="ctr"/>
+          <a:lstStyle/>
+          <a:p>
+            <a:pPr algn="ctr"/>
+            <a:endParaRPr/>
+          </a:p>
+        </p:txBody>
+      </p:sp>
+      <p:sp>
+        <p:nvSpPr>
+          <p:cNvPr id="34" name="TextBox 33"/>
+          <p:cNvSpPr txBox="1"/>
+          <p:nvPr/>
+        </p:nvSpPr>
+        <p:spPr>
+          <a:xfrm>
+            <a:off x="10195559" y="2286000"/>
+            <a:ext cx="1600199" cy="365760"/>
+          </a:xfrm>
+          <a:prstGeom prst="rect">
+            <a:avLst/>
+          </a:prstGeom>
+          <a:noFill/>
+        </p:spPr>
+        <p:txBody>
+          <a:bodyPr wrap="square" anchor="t">
+            <a:spAutoFit/>
+          </a:bodyPr>
+          <a:lstStyle/>
+          <a:p>
+            <a:pPr algn="ctr">
+              <a:spcBef>
+                <a:spcPts val="0"/>
+              </a:spcBef>
+              <a:spcAft>
+                <a:spcPts val="200"/>
+              </a:spcAft>
+            </a:pPr>
+            <a:r>
+              <a:rPr sz="1350" b="1">
+                <a:solidFill>
+                  <a:srgbClr val="2E2A26"/>
+                </a:solidFill>
+                <a:latin typeface="Liberation Sans"/>
+              </a:rPr>
+              <a:t>SERVE</a:t>
+            </a:r>
+          </a:p>
+        </p:txBody>
+      </p:sp>
+      <p:sp>
+        <p:nvSpPr>
+          <p:cNvPr id="35" name="TextBox 34"/>
+          <p:cNvSpPr txBox="1"/>
+          <p:nvPr/>
+        </p:nvSpPr>
+        <p:spPr>
+          <a:xfrm>
+            <a:off x="10195559" y="2788920"/>
+            <a:ext cx="1600199" cy="914400"/>
+          </a:xfrm>
+          <a:prstGeom prst="rect">
+            <a:avLst/>
+          </a:prstGeom>
+          <a:noFill/>
+        </p:spPr>
+        <p:txBody>
+          <a:bodyPr wrap="square" anchor="t">
+            <a:spAutoFit/>
+          </a:bodyPr>
+          <a:lstStyle/>
+          <a:p>
+            <a:pPr algn="ctr">
+              <a:spcBef>
+                <a:spcPts val="0"/>
+              </a:spcBef>
+              <a:spcAft>
+                <a:spcPts val="200"/>
+              </a:spcAft>
+            </a:pPr>
+            <a:r>
+              <a:rPr sz="1250" b="0">
+                <a:solidFill>
+                  <a:srgbClr val="6E645B"/>
+                </a:solidFill>
+                <a:latin typeface="Liberation Sans"/>
+              </a:rPr>
+              <a:t>Query flow:
+intent → rank → cards</a:t>
+            </a:r>
+          </a:p>
+        </p:txBody>
+      </p:sp>
+      <p:sp>
+        <p:nvSpPr>
+          <p:cNvPr id="36" name="TextBox 35"/>
+          <p:cNvSpPr txBox="1"/>
+          <p:nvPr/>
+        </p:nvSpPr>
+        <p:spPr>
+          <a:xfrm>
+            <a:off x="822960" y="4480560"/>
+            <a:ext cx="10515600" cy="1087477"/>
+          </a:xfrm>
+          <a:prstGeom prst="rect">
+            <a:avLst/>
+          </a:prstGeom>
+          <a:noFill/>
+        </p:spPr>
+        <p:txBody>
           <a:bodyPr wrap="square">
             <a:spAutoFit/>
           </a:bodyPr>
           <a:lstStyle/>
           <a:p>
-            <a:r>
-              <a:rPr lang="en-US" sz="3200" dirty="0"/>
-              <a:t>https://heartfood.vercel.app/</a:t>
+            <a:pPr>
+              <a:spcBef>
+                <a:spcPts val="0"/>
+              </a:spcBef>
+              <a:spcAft>
+                <a:spcPts val="800"/>
+              </a:spcAft>
+            </a:pPr>
+            <a:r>
+              <a:rPr sz="1450" dirty="0">
+                <a:solidFill>
+                  <a:srgbClr val="C96F4A"/>
+                </a:solidFill>
+                <a:latin typeface="Liberation Sans"/>
+              </a:rPr>
+              <a:t>•  </a:t>
+            </a:r>
+            <a:r>
+              <a:rPr sz="1450" b="1" dirty="0">
+                <a:solidFill>
+                  <a:srgbClr val="2E2A26"/>
+                </a:solidFill>
+                <a:latin typeface="Liberation Sans"/>
+              </a:rPr>
+              <a:t>Today (hackathon): </a:t>
+            </a:r>
+            <a:r>
+              <a:rPr sz="1450" b="0" dirty="0">
+                <a:solidFill>
+                  <a:srgbClr val="2E2A26"/>
+                </a:solidFill>
+                <a:latin typeface="Liberation Sans"/>
+              </a:rPr>
+              <a:t>hand-curated dataset, ~</a:t>
+            </a:r>
+            <a:r>
+              <a:rPr lang="en-US" sz="1450" dirty="0">
+                <a:solidFill>
+                  <a:srgbClr val="2E2A26"/>
+                </a:solidFill>
+                <a:latin typeface="Liberation Sans"/>
+              </a:rPr>
+              <a:t>15</a:t>
+            </a:r>
+            <a:r>
+              <a:rPr sz="1450" b="0" dirty="0">
+                <a:solidFill>
+                  <a:srgbClr val="2E2A26"/>
+                </a:solidFill>
+                <a:latin typeface="Liberation Sans"/>
+              </a:rPr>
+              <a:t> Greater Hartford sites</a:t>
+            </a:r>
+            <a:br>
+              <a:rPr lang="en-US" sz="1450" b="0" dirty="0">
+                <a:solidFill>
+                  <a:srgbClr val="2E2A26"/>
+                </a:solidFill>
+                <a:latin typeface="Liberation Sans"/>
+              </a:rPr>
+            </a:br>
+            <a:r>
+              <a:rPr lang="en-US" sz="1450" b="0" dirty="0">
+                <a:solidFill>
+                  <a:srgbClr val="2E2A26"/>
+                </a:solidFill>
+                <a:latin typeface="Liberation Sans"/>
+              </a:rPr>
+              <a:t>    </a:t>
+            </a:r>
+            <a:r>
+              <a:rPr lang="en-US" sz="1450" dirty="0">
+                <a:solidFill>
+                  <a:srgbClr val="2E2A26"/>
+                </a:solidFill>
+                <a:latin typeface="Liberation Sans"/>
+              </a:rPr>
+              <a:t>E</a:t>
+            </a:r>
+            <a:r>
+              <a:rPr sz="1450" b="0" dirty="0">
+                <a:solidFill>
+                  <a:srgbClr val="2E2A26"/>
+                </a:solidFill>
+                <a:latin typeface="Liberation Sans"/>
+              </a:rPr>
+              <a:t>very row has name, address, type, and phone or hours. Demo runs client-side</a:t>
+            </a:r>
+            <a:r>
+              <a:rPr lang="en-US" sz="1450" dirty="0">
+                <a:solidFill>
+                  <a:srgbClr val="2E2A26"/>
+                </a:solidFill>
+                <a:latin typeface="Liberation Sans"/>
+              </a:rPr>
+              <a:t> and is deployed online already.</a:t>
+            </a:r>
+            <a:endParaRPr sz="1450" b="0" dirty="0">
+              <a:solidFill>
+                <a:srgbClr val="2E2A26"/>
+              </a:solidFill>
+              <a:latin typeface="Liberation Sans"/>
+            </a:endParaRPr>
+          </a:p>
+          <a:p>
+            <a:pPr>
+              <a:spcBef>
+                <a:spcPts val="0"/>
+              </a:spcBef>
+              <a:spcAft>
+                <a:spcPts val="800"/>
+              </a:spcAft>
+            </a:pPr>
+            <a:r>
+              <a:rPr sz="1450" dirty="0">
+                <a:solidFill>
+                  <a:srgbClr val="C96F4A"/>
+                </a:solidFill>
+                <a:latin typeface="Liberation Sans"/>
+              </a:rPr>
+              <a:t>•  </a:t>
+            </a:r>
+            <a:r>
+              <a:rPr sz="1450" b="1" dirty="0">
+                <a:solidFill>
+                  <a:srgbClr val="2E2A26"/>
+                </a:solidFill>
+                <a:latin typeface="Liberation Sans"/>
+              </a:rPr>
+              <a:t>Next: </a:t>
+            </a:r>
+            <a:r>
+              <a:rPr lang="en-US" sz="1450" dirty="0">
+                <a:solidFill>
+                  <a:srgbClr val="2E2A26"/>
+                </a:solidFill>
+                <a:latin typeface="Liberation Sans"/>
+              </a:rPr>
+              <a:t>Data scraped every 6 hours</a:t>
+            </a:r>
+            <a:r>
+              <a:rPr sz="1450" b="0" dirty="0">
+                <a:solidFill>
+                  <a:srgbClr val="2E2A26"/>
+                </a:solidFill>
+                <a:latin typeface="Liberation Sans"/>
+              </a:rPr>
+              <a:t> + 211 CT / Foodshare partnership for live hours;</a:t>
+            </a:r>
+            <a:br>
+              <a:rPr lang="en-US" sz="1450" b="0" dirty="0">
+                <a:solidFill>
+                  <a:srgbClr val="2E2A26"/>
+                </a:solidFill>
+                <a:latin typeface="Liberation Sans"/>
+              </a:rPr>
+            </a:br>
+            <a:r>
+              <a:rPr lang="en-US" sz="1450" b="0" dirty="0">
+                <a:solidFill>
+                  <a:srgbClr val="2E2A26"/>
+                </a:solidFill>
+                <a:latin typeface="Liberation Sans"/>
+              </a:rPr>
+              <a:t>              </a:t>
+            </a:r>
+            <a:r>
+              <a:rPr sz="1450" b="0" dirty="0">
+                <a:solidFill>
+                  <a:srgbClr val="2E2A26"/>
+                </a:solidFill>
+                <a:latin typeface="Liberation Sans"/>
+              </a:rPr>
+              <a:t>volunteer-reported updates as the freshness loop.</a:t>
             </a:r>
           </a:p>
         </p:txBody>
@@ -8598,50 +9520,6 @@
       </p:grpSpPr>
       <p:sp>
         <p:nvSpPr>
-          <p:cNvPr id="2" name="Rectangle 1"/>
-          <p:cNvSpPr/>
-          <p:nvPr/>
-        </p:nvSpPr>
-        <p:spPr>
-          <a:xfrm>
-            <a:off x="0" y="0"/>
-            <a:ext cx="12191695" cy="6858000"/>
-          </a:xfrm>
-          <a:prstGeom prst="rect">
-            <a:avLst/>
-          </a:prstGeom>
-          <a:solidFill>
-            <a:srgbClr val="FAF6EF"/>
-          </a:solidFill>
-          <a:ln>
-            <a:noFill/>
-          </a:ln>
-        </p:spPr>
-        <p:style>
-          <a:lnRef idx="1">
-            <a:schemeClr val="accent1"/>
-          </a:lnRef>
-          <a:fillRef idx="3">
-            <a:schemeClr val="accent1"/>
-          </a:fillRef>
-          <a:effectRef idx="2">
-            <a:schemeClr val="accent1"/>
-          </a:effectRef>
-          <a:fontRef idx="minor">
-            <a:schemeClr val="lt1"/>
-          </a:fontRef>
-        </p:style>
-        <p:txBody>
-          <a:bodyPr rtlCol="0" anchor="ctr"/>
-          <a:lstStyle/>
-          <a:p>
-            <a:pPr algn="ctr"/>
-            <a:endParaRPr/>
-          </a:p>
-        </p:txBody>
-      </p:sp>
-      <p:sp>
-        <p:nvSpPr>
           <p:cNvPr id="3" name="Rounded Rectangle 2"/>
           <p:cNvSpPr/>
           <p:nvPr/>
@@ -8694,8 +9572,8 @@
         </p:nvSpPr>
         <p:spPr>
           <a:xfrm>
-            <a:off x="548640" y="310896"/>
-            <a:ext cx="3108960" cy="310896"/>
+            <a:off x="548640" y="339386"/>
+            <a:ext cx="3108960" cy="253916"/>
           </a:xfrm>
           <a:prstGeom prst="rect">
             <a:avLst/>
@@ -8717,14 +9595,20 @@
               </a:spcAft>
             </a:pPr>
             <a:r>
-              <a:rPr sz="1050" b="1">
+              <a:rPr lang="en-US" sz="1050" b="1" dirty="0">
                 <a:solidFill>
                   <a:srgbClr val="FFFFFF"/>
                 </a:solidFill>
                 <a:latin typeface="Liberation Sans"/>
               </a:rPr>
-              <a:t>DATA PIPELINE  ·  15 SECONDS</a:t>
-            </a:r>
+              <a:t>LIVE DEMO with Avant</a:t>
+            </a:r>
+            <a:endParaRPr sz="1050" b="1" dirty="0">
+              <a:solidFill>
+                <a:srgbClr val="FFFFFF"/>
+              </a:solidFill>
+              <a:latin typeface="Liberation Sans"/>
+            </a:endParaRPr>
           </a:p>
         </p:txBody>
       </p:sp>
@@ -8737,7 +9621,7 @@
         <p:spPr>
           <a:xfrm>
             <a:off x="548640" y="749808"/>
-            <a:ext cx="11064240" cy="1164421"/>
+            <a:ext cx="11064240" cy="615553"/>
           </a:xfrm>
           <a:prstGeom prst="rect">
             <a:avLst/>
@@ -8750,27 +9634,23 @@
           </a:bodyPr>
           <a:lstStyle/>
           <a:p>
-            <a:pPr>
+            <a:pPr algn="l">
+              <a:spcBef>
+                <a:spcPts val="0"/>
+              </a:spcBef>
               <a:spcAft>
                 <a:spcPts val="200"/>
               </a:spcAft>
             </a:pPr>
             <a:r>
-              <a:rPr lang="en-US" sz="3400" b="1" dirty="0">
+              <a:rPr lang="en-US" sz="3400" b="1" dirty="0" err="1">
                 <a:solidFill>
                   <a:srgbClr val="2E2A26"/>
                 </a:solidFill>
                 <a:latin typeface="DejaVu Serif"/>
               </a:rPr>
-              <a:t>AI where it matters: </a:t>
-            </a:r>
-          </a:p>
-          <a:p>
-            <a:pPr>
-              <a:spcAft>
-                <a:spcPts val="200"/>
-              </a:spcAft>
-            </a:pPr>
+              <a:t>Heartfood</a:t>
+            </a:r>
             <a:r>
               <a:rPr lang="en-US" sz="3400" b="1" dirty="0">
                 <a:solidFill>
@@ -8778,7 +9658,7 @@
                 </a:solidFill>
                 <a:latin typeface="DejaVu Serif"/>
               </a:rPr>
-              <a:t>	Fresh data daily</a:t>
+              <a:t> prototype app</a:t>
             </a:r>
             <a:endParaRPr sz="3400" b="1" dirty="0">
               <a:solidFill>
@@ -8791,67 +9671,17 @@
       </p:sp>
       <p:sp>
         <p:nvSpPr>
-          <p:cNvPr id="8" name="Rounded Rectangle 7"/>
+          <p:cNvPr id="6" name="Rectangle 5"/>
           <p:cNvSpPr/>
           <p:nvPr/>
         </p:nvSpPr>
         <p:spPr>
           <a:xfrm>
-            <a:off x="548640" y="2103120"/>
-            <a:ext cx="1874519" cy="1828800"/>
-          </a:xfrm>
-          <a:prstGeom prst="roundRect">
-            <a:avLst>
-              <a:gd name="adj" fmla="val 10000"/>
-            </a:avLst>
-          </a:prstGeom>
-          <a:solidFill>
-            <a:srgbClr val="FFFFFF"/>
-          </a:solidFill>
-          <a:ln w="15875">
-            <a:solidFill>
-              <a:srgbClr val="E2D7C2"/>
-            </a:solidFill>
-          </a:ln>
-        </p:spPr>
-        <p:style>
-          <a:lnRef idx="1">
-            <a:schemeClr val="accent1"/>
-          </a:lnRef>
-          <a:fillRef idx="3">
-            <a:schemeClr val="accent1"/>
-          </a:fillRef>
-          <a:effectRef idx="2">
-            <a:schemeClr val="accent1"/>
-          </a:effectRef>
-          <a:fontRef idx="minor">
-            <a:schemeClr val="lt1"/>
-          </a:fontRef>
-        </p:style>
-        <p:txBody>
-          <a:bodyPr rtlCol="0" anchor="ctr"/>
-          <a:lstStyle/>
-          <a:p>
-            <a:pPr algn="ctr"/>
-            <a:endParaRPr/>
-          </a:p>
-        </p:txBody>
-      </p:sp>
-      <p:sp>
-        <p:nvSpPr>
-          <p:cNvPr id="9" name="Rounded Rectangle 8"/>
-          <p:cNvSpPr/>
-          <p:nvPr/>
-        </p:nvSpPr>
-        <p:spPr>
-          <a:xfrm>
-            <a:off x="548640" y="2103120"/>
-            <a:ext cx="1874519" cy="114300"/>
-          </a:xfrm>
-          <a:prstGeom prst="roundRect">
-            <a:avLst>
-              <a:gd name="adj" fmla="val 50000"/>
-            </a:avLst>
+            <a:off x="548640" y="1481328"/>
+            <a:ext cx="1280160" cy="50800"/>
+          </a:xfrm>
+          <a:prstGeom prst="rect">
+            <a:avLst/>
           </a:prstGeom>
           <a:solidFill>
             <a:srgbClr val="C96F4A"/>
@@ -8885,14 +9715,102 @@
       </p:sp>
       <p:sp>
         <p:nvSpPr>
-          <p:cNvPr id="10" name="TextBox 9"/>
+          <p:cNvPr id="18" name="Rectangle 17"/>
+          <p:cNvSpPr/>
+          <p:nvPr/>
+        </p:nvSpPr>
+        <p:spPr>
+          <a:xfrm>
+            <a:off x="685800" y="6720840"/>
+            <a:ext cx="7132320" cy="38100"/>
+          </a:xfrm>
+          <a:prstGeom prst="rect">
+            <a:avLst/>
+          </a:prstGeom>
+          <a:solidFill>
+            <a:srgbClr val="E2D7C2"/>
+          </a:solidFill>
+          <a:ln>
+            <a:noFill/>
+          </a:ln>
+        </p:spPr>
+        <p:style>
+          <a:lnRef idx="1">
+            <a:schemeClr val="accent1"/>
+          </a:lnRef>
+          <a:fillRef idx="3">
+            <a:schemeClr val="accent1"/>
+          </a:fillRef>
+          <a:effectRef idx="2">
+            <a:schemeClr val="accent1"/>
+          </a:effectRef>
+          <a:fontRef idx="minor">
+            <a:schemeClr val="lt1"/>
+          </a:fontRef>
+        </p:style>
+        <p:txBody>
+          <a:bodyPr rtlCol="0" anchor="ctr"/>
+          <a:lstStyle/>
+          <a:p>
+            <a:pPr algn="ctr"/>
+            <a:endParaRPr/>
+          </a:p>
+        </p:txBody>
+      </p:sp>
+      <p:sp>
+        <p:nvSpPr>
+          <p:cNvPr id="19" name="Rectangle 18"/>
+          <p:cNvSpPr/>
+          <p:nvPr/>
+        </p:nvSpPr>
+        <p:spPr>
+          <a:xfrm>
+            <a:off x="685800" y="7543800"/>
+            <a:ext cx="7132320" cy="38100"/>
+          </a:xfrm>
+          <a:prstGeom prst="rect">
+            <a:avLst/>
+          </a:prstGeom>
+          <a:solidFill>
+            <a:srgbClr val="E2D7C2"/>
+          </a:solidFill>
+          <a:ln>
+            <a:noFill/>
+          </a:ln>
+        </p:spPr>
+        <p:style>
+          <a:lnRef idx="1">
+            <a:schemeClr val="accent1"/>
+          </a:lnRef>
+          <a:fillRef idx="3">
+            <a:schemeClr val="accent1"/>
+          </a:fillRef>
+          <a:effectRef idx="2">
+            <a:schemeClr val="accent1"/>
+          </a:effectRef>
+          <a:fontRef idx="minor">
+            <a:schemeClr val="lt1"/>
+          </a:fontRef>
+        </p:style>
+        <p:txBody>
+          <a:bodyPr rtlCol="0" anchor="ctr"/>
+          <a:lstStyle/>
+          <a:p>
+            <a:pPr algn="ctr"/>
+            <a:endParaRPr/>
+          </a:p>
+        </p:txBody>
+      </p:sp>
+      <p:sp>
+        <p:nvSpPr>
+          <p:cNvPr id="44" name="TextBox 43"/>
           <p:cNvSpPr txBox="1"/>
           <p:nvPr/>
         </p:nvSpPr>
         <p:spPr>
           <a:xfrm>
-            <a:off x="685800" y="2286000"/>
-            <a:ext cx="1600199" cy="365760"/>
+            <a:off x="9006840" y="3566160"/>
+            <a:ext cx="2377440" cy="365760"/>
           </a:xfrm>
           <a:prstGeom prst="rect">
             <a:avLst/>
@@ -8901,6 +9819,90 @@
         </p:spPr>
         <p:txBody>
           <a:bodyPr wrap="square" anchor="t">
+            <a:spAutoFit/>
+          </a:bodyPr>
+          <a:lstStyle/>
+          <a:p>
+            <a:pPr algn="l">
+              <a:spcBef>
+                <a:spcPts val="0"/>
+              </a:spcBef>
+              <a:spcAft>
+                <a:spcPts val="200"/>
+              </a:spcAft>
+            </a:pPr>
+            <a:r>
+              <a:rPr sz="1400" b="1">
+                <a:solidFill>
+                  <a:srgbClr val="FFFFFF"/>
+                </a:solidFill>
+                <a:latin typeface="Liberation Sans"/>
+              </a:rPr>
+              <a:t>Bus 33</a:t>
+            </a:r>
+          </a:p>
+        </p:txBody>
+      </p:sp>
+      <p:sp>
+        <p:nvSpPr>
+          <p:cNvPr id="47" name="TextBox 46"/>
+          <p:cNvSpPr txBox="1"/>
+          <p:nvPr/>
+        </p:nvSpPr>
+        <p:spPr>
+          <a:xfrm>
+            <a:off x="9006840" y="4526280"/>
+            <a:ext cx="2377440" cy="365760"/>
+          </a:xfrm>
+          <a:prstGeom prst="rect">
+            <a:avLst/>
+          </a:prstGeom>
+          <a:noFill/>
+        </p:spPr>
+        <p:txBody>
+          <a:bodyPr wrap="square" anchor="t">
+            <a:spAutoFit/>
+          </a:bodyPr>
+          <a:lstStyle/>
+          <a:p>
+            <a:pPr algn="l">
+              <a:spcBef>
+                <a:spcPts val="0"/>
+              </a:spcBef>
+              <a:spcAft>
+                <a:spcPts val="200"/>
+              </a:spcAft>
+            </a:pPr>
+            <a:r>
+              <a:rPr sz="1400" b="1">
+                <a:solidFill>
+                  <a:srgbClr val="FFFFFF"/>
+                </a:solidFill>
+                <a:latin typeface="Liberation Sans"/>
+              </a:rPr>
+              <a:t>Walk 3 min</a:t>
+            </a:r>
+          </a:p>
+        </p:txBody>
+      </p:sp>
+      <p:sp>
+        <p:nvSpPr>
+          <p:cNvPr id="50" name="TextBox 49"/>
+          <p:cNvSpPr txBox="1"/>
+          <p:nvPr/>
+        </p:nvSpPr>
+        <p:spPr>
+          <a:xfrm>
+            <a:off x="8595360" y="5636661"/>
+            <a:ext cx="2788920" cy="284693"/>
+          </a:xfrm>
+          <a:prstGeom prst="rect">
+            <a:avLst/>
+          </a:prstGeom>
+          <a:noFill/>
+        </p:spPr>
+        <p:txBody>
+          <a:bodyPr wrap="square" anchor="ctr">
             <a:spAutoFit/>
           </a:bodyPr>
           <a:lstStyle/>
@@ -8914,27 +9916,64 @@
               </a:spcAft>
             </a:pPr>
             <a:r>
-              <a:rPr sz="1350" b="1">
-                <a:solidFill>
-                  <a:srgbClr val="C96F4A"/>
+              <a:rPr sz="1250" b="1" dirty="0">
+                <a:solidFill>
+                  <a:srgbClr val="FFFFFF"/>
                 </a:solidFill>
                 <a:latin typeface="Liberation Sans"/>
               </a:rPr>
-              <a:t>SOURCES</a:t>
-            </a:r>
-          </a:p>
-        </p:txBody>
-      </p:sp>
-      <p:sp>
-        <p:nvSpPr>
-          <p:cNvPr id="11" name="TextBox 10"/>
+              <a:t>TAP TOCALL  ·  (860) 728-3201</a:t>
+            </a:r>
+          </a:p>
+        </p:txBody>
+      </p:sp>
+      <p:pic>
+        <p:nvPicPr>
+          <p:cNvPr id="58" name="Picture 57">
+            <a:extLst>
+              <a:ext uri="{FF2B5EF4-FFF2-40B4-BE49-F238E27FC236}">
+                <a16:creationId xmlns:a16="http://schemas.microsoft.com/office/drawing/2014/main" id="{12353F19-6D9F-107B-E911-D6D8ADAD4A76}"/>
+              </a:ext>
+            </a:extLst>
+          </p:cNvPr>
+          <p:cNvPicPr>
+            <a:picLocks noChangeAspect="1"/>
+          </p:cNvPicPr>
+          <p:nvPr/>
+        </p:nvPicPr>
+        <p:blipFill>
+          <a:blip r:embed="rId3"/>
+          <a:srcRect t="7814" b="5351"/>
+          <a:stretch>
+            <a:fillRect/>
+          </a:stretch>
+        </p:blipFill>
+        <p:spPr>
+          <a:xfrm>
+            <a:off x="3733101" y="1280061"/>
+            <a:ext cx="5147280" cy="4469659"/>
+          </a:xfrm>
+          <a:prstGeom prst="rect">
+            <a:avLst/>
+          </a:prstGeom>
+        </p:spPr>
+      </p:pic>
+      <p:sp>
+        <p:nvSpPr>
+          <p:cNvPr id="60" name="TextBox 59">
+            <a:extLst>
+              <a:ext uri="{FF2B5EF4-FFF2-40B4-BE49-F238E27FC236}">
+                <a16:creationId xmlns:a16="http://schemas.microsoft.com/office/drawing/2014/main" id="{50FB8D79-81AA-8647-391F-D72881F66235}"/>
+              </a:ext>
+            </a:extLst>
+          </p:cNvPr>
           <p:cNvSpPr txBox="1"/>
           <p:nvPr/>
         </p:nvSpPr>
         <p:spPr>
           <a:xfrm>
-            <a:off x="685800" y="2788920"/>
-            <a:ext cx="1600199" cy="914400"/>
+            <a:off x="3596641" y="5664420"/>
+            <a:ext cx="6534554" cy="584775"/>
           </a:xfrm>
           <a:prstGeom prst="rect">
             <a:avLst/>
@@ -8942,1004 +9981,48 @@
           <a:noFill/>
         </p:spPr>
         <p:txBody>
-          <a:bodyPr wrap="square" anchor="t">
+          <a:bodyPr wrap="square">
             <a:spAutoFit/>
           </a:bodyPr>
           <a:lstStyle/>
           <a:p>
-            <a:pPr algn="ctr">
-              <a:spcBef>
-                <a:spcPts val="0"/>
-              </a:spcBef>
-              <a:spcAft>
-                <a:spcPts val="200"/>
-              </a:spcAft>
-            </a:pPr>
-            <a:r>
-              <a:rPr sz="1250" b="0">
-                <a:solidFill>
-                  <a:srgbClr val="6E645B"/>
-                </a:solidFill>
-                <a:latin typeface="Liberation Sans"/>
-              </a:rPr>
-              <a:t>CT Foodshare
-211 CT
-USDA SNAP CSV</a:t>
-            </a:r>
-          </a:p>
-        </p:txBody>
-      </p:sp>
-      <p:cxnSp>
-        <p:nvCxnSpPr>
-          <p:cNvPr id="12" name="Connector 11"/>
-          <p:cNvCxnSpPr/>
+            <a:r>
+              <a:rPr lang="en-US" sz="3200" dirty="0"/>
+              <a:t>https://heartfood.vercel.app/</a:t>
+            </a:r>
+          </a:p>
+        </p:txBody>
+      </p:sp>
+      <p:pic>
+        <p:nvPicPr>
+          <p:cNvPr id="7" name="Picture 6">
+            <a:extLst>
+              <a:ext uri="{FF2B5EF4-FFF2-40B4-BE49-F238E27FC236}">
+                <a16:creationId xmlns:a16="http://schemas.microsoft.com/office/drawing/2014/main" id="{0F434015-F312-AD1A-CCE8-BE5C288C757E}"/>
+              </a:ext>
+            </a:extLst>
+          </p:cNvPr>
+          <p:cNvPicPr>
+            <a:picLocks noChangeAspect="1"/>
+          </p:cNvPicPr>
           <p:nvPr/>
-        </p:nvCxnSpPr>
-        <p:spPr>
-          <a:xfrm>
-            <a:off x="2496312" y="3017520"/>
-            <a:ext cx="356616" cy="0"/>
-          </a:xfrm>
-          <a:prstGeom prst="line">
-            <a:avLst/>
-          </a:prstGeom>
-          <a:ln w="38100">
-            <a:solidFill>
-              <a:srgbClr val="A85A38"/>
-            </a:solidFill>
-          </a:ln>
-        </p:spPr>
-        <p:style>
-          <a:lnRef idx="2">
-            <a:schemeClr val="accent1"/>
-          </a:lnRef>
-          <a:fillRef idx="0">
-            <a:schemeClr val="accent1"/>
-          </a:fillRef>
-          <a:effectRef idx="1">
-            <a:schemeClr val="accent1"/>
-          </a:effectRef>
-          <a:fontRef idx="minor">
-            <a:schemeClr val="tx1"/>
-          </a:fontRef>
-        </p:style>
-      </p:cxnSp>
-      <p:sp>
-        <p:nvSpPr>
-          <p:cNvPr id="14" name="Rounded Rectangle 13"/>
-          <p:cNvSpPr/>
-          <p:nvPr/>
-        </p:nvSpPr>
-        <p:spPr>
-          <a:xfrm>
-            <a:off x="2926079" y="2103120"/>
-            <a:ext cx="1874519" cy="1828800"/>
-          </a:xfrm>
-          <a:prstGeom prst="roundRect">
-            <a:avLst>
-              <a:gd name="adj" fmla="val 10000"/>
-            </a:avLst>
-          </a:prstGeom>
-          <a:solidFill>
-            <a:srgbClr val="FFFFFF"/>
-          </a:solidFill>
-          <a:ln w="15875">
-            <a:solidFill>
-              <a:srgbClr val="E2D7C2"/>
-            </a:solidFill>
-          </a:ln>
-        </p:spPr>
-        <p:style>
-          <a:lnRef idx="1">
-            <a:schemeClr val="accent1"/>
-          </a:lnRef>
-          <a:fillRef idx="3">
-            <a:schemeClr val="accent1"/>
-          </a:fillRef>
-          <a:effectRef idx="2">
-            <a:schemeClr val="accent1"/>
-          </a:effectRef>
-          <a:fontRef idx="minor">
-            <a:schemeClr val="lt1"/>
-          </a:fontRef>
-        </p:style>
-        <p:txBody>
-          <a:bodyPr rtlCol="0" anchor="ctr"/>
-          <a:lstStyle/>
-          <a:p>
-            <a:pPr algn="ctr"/>
-            <a:endParaRPr/>
-          </a:p>
-        </p:txBody>
-      </p:sp>
-      <p:sp>
-        <p:nvSpPr>
-          <p:cNvPr id="15" name="Rounded Rectangle 14"/>
-          <p:cNvSpPr/>
-          <p:nvPr/>
-        </p:nvSpPr>
-        <p:spPr>
-          <a:xfrm>
-            <a:off x="2926079" y="2103120"/>
-            <a:ext cx="1874519" cy="114300"/>
-          </a:xfrm>
-          <a:prstGeom prst="roundRect">
-            <a:avLst>
-              <a:gd name="adj" fmla="val 50000"/>
-            </a:avLst>
-          </a:prstGeom>
-          <a:solidFill>
-            <a:srgbClr val="D9A441"/>
-          </a:solidFill>
-          <a:ln>
-            <a:noFill/>
-          </a:ln>
-        </p:spPr>
-        <p:style>
-          <a:lnRef idx="1">
-            <a:schemeClr val="accent1"/>
-          </a:lnRef>
-          <a:fillRef idx="3">
-            <a:schemeClr val="accent1"/>
-          </a:fillRef>
-          <a:effectRef idx="2">
-            <a:schemeClr val="accent1"/>
-          </a:effectRef>
-          <a:fontRef idx="minor">
-            <a:schemeClr val="lt1"/>
-          </a:fontRef>
-        </p:style>
-        <p:txBody>
-          <a:bodyPr rtlCol="0" anchor="ctr"/>
-          <a:lstStyle/>
-          <a:p>
-            <a:pPr algn="ctr"/>
-            <a:endParaRPr/>
-          </a:p>
-        </p:txBody>
-      </p:sp>
-      <p:sp>
-        <p:nvSpPr>
-          <p:cNvPr id="16" name="TextBox 15"/>
-          <p:cNvSpPr txBox="1"/>
-          <p:nvPr/>
-        </p:nvSpPr>
-        <p:spPr>
-          <a:xfrm>
-            <a:off x="3063239" y="2286000"/>
-            <a:ext cx="1600199" cy="365760"/>
+        </p:nvPicPr>
+        <p:blipFill>
+          <a:blip r:embed="rId4"/>
+          <a:stretch>
+            <a:fillRect/>
+          </a:stretch>
+        </p:blipFill>
+        <p:spPr>
+          <a:xfrm>
+            <a:off x="650355" y="2316988"/>
+            <a:ext cx="2905530" cy="2057687"/>
           </a:xfrm>
           <a:prstGeom prst="rect">
             <a:avLst/>
           </a:prstGeom>
-          <a:noFill/>
-        </p:spPr>
-        <p:txBody>
-          <a:bodyPr wrap="square" anchor="t">
-            <a:spAutoFit/>
-          </a:bodyPr>
-          <a:lstStyle/>
-          <a:p>
-            <a:pPr algn="ctr">
-              <a:spcBef>
-                <a:spcPts val="0"/>
-              </a:spcBef>
-              <a:spcAft>
-                <a:spcPts val="200"/>
-              </a:spcAft>
-            </a:pPr>
-            <a:r>
-              <a:rPr sz="1350" b="1">
-                <a:solidFill>
-                  <a:srgbClr val="D9A441"/>
-                </a:solidFill>
-                <a:latin typeface="Liberation Sans"/>
-              </a:rPr>
-              <a:t>NORMALIZE</a:t>
-            </a:r>
-          </a:p>
-        </p:txBody>
-      </p:sp>
-      <p:sp>
-        <p:nvSpPr>
-          <p:cNvPr id="17" name="TextBox 16"/>
-          <p:cNvSpPr txBox="1"/>
-          <p:nvPr/>
-        </p:nvSpPr>
-        <p:spPr>
-          <a:xfrm>
-            <a:off x="3063239" y="2788920"/>
-            <a:ext cx="1600199" cy="914400"/>
-          </a:xfrm>
-          <a:prstGeom prst="rect">
-            <a:avLst/>
-          </a:prstGeom>
-          <a:noFill/>
-        </p:spPr>
-        <p:txBody>
-          <a:bodyPr wrap="square" anchor="t">
-            <a:spAutoFit/>
-          </a:bodyPr>
-          <a:lstStyle/>
-          <a:p>
-            <a:pPr algn="ctr">
-              <a:spcBef>
-                <a:spcPts val="0"/>
-              </a:spcBef>
-              <a:spcAft>
-                <a:spcPts val="200"/>
-              </a:spcAft>
-            </a:pPr>
-            <a:r>
-              <a:rPr sz="1250" b="0">
-                <a:solidFill>
-                  <a:srgbClr val="6E645B"/>
-                </a:solidFill>
-                <a:latin typeface="Liberation Sans"/>
-              </a:rPr>
-              <a:t>LLM reconciles messy
-hours → clean schema</a:t>
-            </a:r>
-          </a:p>
-        </p:txBody>
-      </p:sp>
-      <p:cxnSp>
-        <p:nvCxnSpPr>
-          <p:cNvPr id="18" name="Connector 17"/>
-          <p:cNvCxnSpPr/>
-          <p:nvPr/>
-        </p:nvCxnSpPr>
-        <p:spPr>
-          <a:xfrm>
-            <a:off x="4873752" y="3017520"/>
-            <a:ext cx="356616" cy="0"/>
-          </a:xfrm>
-          <a:prstGeom prst="line">
-            <a:avLst/>
-          </a:prstGeom>
-          <a:ln w="38100">
-            <a:solidFill>
-              <a:srgbClr val="A85A38"/>
-            </a:solidFill>
-          </a:ln>
-        </p:spPr>
-        <p:style>
-          <a:lnRef idx="2">
-            <a:schemeClr val="accent1"/>
-          </a:lnRef>
-          <a:fillRef idx="0">
-            <a:schemeClr val="accent1"/>
-          </a:fillRef>
-          <a:effectRef idx="1">
-            <a:schemeClr val="accent1"/>
-          </a:effectRef>
-          <a:fontRef idx="minor">
-            <a:schemeClr val="tx1"/>
-          </a:fontRef>
-        </p:style>
-      </p:cxnSp>
-      <p:sp>
-        <p:nvSpPr>
-          <p:cNvPr id="20" name="Rounded Rectangle 19"/>
-          <p:cNvSpPr/>
-          <p:nvPr/>
-        </p:nvSpPr>
-        <p:spPr>
-          <a:xfrm>
-            <a:off x="5303519" y="2103120"/>
-            <a:ext cx="1874519" cy="1828800"/>
-          </a:xfrm>
-          <a:prstGeom prst="roundRect">
-            <a:avLst>
-              <a:gd name="adj" fmla="val 10000"/>
-            </a:avLst>
-          </a:prstGeom>
-          <a:solidFill>
-            <a:srgbClr val="FFFFFF"/>
-          </a:solidFill>
-          <a:ln w="15875">
-            <a:solidFill>
-              <a:srgbClr val="E2D7C2"/>
-            </a:solidFill>
-          </a:ln>
-        </p:spPr>
-        <p:style>
-          <a:lnRef idx="1">
-            <a:schemeClr val="accent1"/>
-          </a:lnRef>
-          <a:fillRef idx="3">
-            <a:schemeClr val="accent1"/>
-          </a:fillRef>
-          <a:effectRef idx="2">
-            <a:schemeClr val="accent1"/>
-          </a:effectRef>
-          <a:fontRef idx="minor">
-            <a:schemeClr val="lt1"/>
-          </a:fontRef>
-        </p:style>
-        <p:txBody>
-          <a:bodyPr rtlCol="0" anchor="ctr"/>
-          <a:lstStyle/>
-          <a:p>
-            <a:pPr algn="ctr"/>
-            <a:endParaRPr/>
-          </a:p>
-        </p:txBody>
-      </p:sp>
-      <p:sp>
-        <p:nvSpPr>
-          <p:cNvPr id="21" name="Rounded Rectangle 20"/>
-          <p:cNvSpPr/>
-          <p:nvPr/>
-        </p:nvSpPr>
-        <p:spPr>
-          <a:xfrm>
-            <a:off x="5303519" y="2103120"/>
-            <a:ext cx="1874519" cy="114300"/>
-          </a:xfrm>
-          <a:prstGeom prst="roundRect">
-            <a:avLst>
-              <a:gd name="adj" fmla="val 50000"/>
-            </a:avLst>
-          </a:prstGeom>
-          <a:solidFill>
-            <a:srgbClr val="5F7A52"/>
-          </a:solidFill>
-          <a:ln>
-            <a:noFill/>
-          </a:ln>
-        </p:spPr>
-        <p:style>
-          <a:lnRef idx="1">
-            <a:schemeClr val="accent1"/>
-          </a:lnRef>
-          <a:fillRef idx="3">
-            <a:schemeClr val="accent1"/>
-          </a:fillRef>
-          <a:effectRef idx="2">
-            <a:schemeClr val="accent1"/>
-          </a:effectRef>
-          <a:fontRef idx="minor">
-            <a:schemeClr val="lt1"/>
-          </a:fontRef>
-        </p:style>
-        <p:txBody>
-          <a:bodyPr rtlCol="0" anchor="ctr"/>
-          <a:lstStyle/>
-          <a:p>
-            <a:pPr algn="ctr"/>
-            <a:endParaRPr/>
-          </a:p>
-        </p:txBody>
-      </p:sp>
-      <p:sp>
-        <p:nvSpPr>
-          <p:cNvPr id="22" name="TextBox 21"/>
-          <p:cNvSpPr txBox="1"/>
-          <p:nvPr/>
-        </p:nvSpPr>
-        <p:spPr>
-          <a:xfrm>
-            <a:off x="5440679" y="2286000"/>
-            <a:ext cx="1600199" cy="365760"/>
-          </a:xfrm>
-          <a:prstGeom prst="rect">
-            <a:avLst/>
-          </a:prstGeom>
-          <a:noFill/>
-        </p:spPr>
-        <p:txBody>
-          <a:bodyPr wrap="square" anchor="t">
-            <a:spAutoFit/>
-          </a:bodyPr>
-          <a:lstStyle/>
-          <a:p>
-            <a:pPr algn="ctr">
-              <a:spcBef>
-                <a:spcPts val="0"/>
-              </a:spcBef>
-              <a:spcAft>
-                <a:spcPts val="200"/>
-              </a:spcAft>
-            </a:pPr>
-            <a:r>
-              <a:rPr sz="1350" b="1">
-                <a:solidFill>
-                  <a:srgbClr val="5F7A52"/>
-                </a:solidFill>
-                <a:latin typeface="Liberation Sans"/>
-              </a:rPr>
-              <a:t>INDEX</a:t>
-            </a:r>
-          </a:p>
-        </p:txBody>
-      </p:sp>
-      <p:sp>
-        <p:nvSpPr>
-          <p:cNvPr id="23" name="TextBox 22"/>
-          <p:cNvSpPr txBox="1"/>
-          <p:nvPr/>
-        </p:nvSpPr>
-        <p:spPr>
-          <a:xfrm>
-            <a:off x="5440679" y="2788920"/>
-            <a:ext cx="1600199" cy="914400"/>
-          </a:xfrm>
-          <a:prstGeom prst="rect">
-            <a:avLst/>
-          </a:prstGeom>
-          <a:noFill/>
-        </p:spPr>
-        <p:txBody>
-          <a:bodyPr wrap="square" anchor="t">
-            <a:spAutoFit/>
-          </a:bodyPr>
-          <a:lstStyle/>
-          <a:p>
-            <a:pPr algn="ctr">
-              <a:spcBef>
-                <a:spcPts val="0"/>
-              </a:spcBef>
-              <a:spcAft>
-                <a:spcPts val="200"/>
-              </a:spcAft>
-            </a:pPr>
-            <a:r>
-              <a:rPr sz="1250" b="0">
-                <a:solidFill>
-                  <a:srgbClr val="6E645B"/>
-                </a:solidFill>
-                <a:latin typeface="Liberation Sans"/>
-              </a:rPr>
-              <a:t>Spatial index
-30 Greater-Hartford sites</a:t>
-            </a:r>
-          </a:p>
-        </p:txBody>
-      </p:sp>
-      <p:cxnSp>
-        <p:nvCxnSpPr>
-          <p:cNvPr id="24" name="Connector 23"/>
-          <p:cNvCxnSpPr/>
-          <p:nvPr/>
-        </p:nvCxnSpPr>
-        <p:spPr>
-          <a:xfrm>
-            <a:off x="7251191" y="3017520"/>
-            <a:ext cx="356616" cy="0"/>
-          </a:xfrm>
-          <a:prstGeom prst="line">
-            <a:avLst/>
-          </a:prstGeom>
-          <a:ln w="38100">
-            <a:solidFill>
-              <a:srgbClr val="A85A38"/>
-            </a:solidFill>
-          </a:ln>
-        </p:spPr>
-        <p:style>
-          <a:lnRef idx="2">
-            <a:schemeClr val="accent1"/>
-          </a:lnRef>
-          <a:fillRef idx="0">
-            <a:schemeClr val="accent1"/>
-          </a:fillRef>
-          <a:effectRef idx="1">
-            <a:schemeClr val="accent1"/>
-          </a:effectRef>
-          <a:fontRef idx="minor">
-            <a:schemeClr val="tx1"/>
-          </a:fontRef>
-        </p:style>
-      </p:cxnSp>
-      <p:sp>
-        <p:nvSpPr>
-          <p:cNvPr id="26" name="Rounded Rectangle 25"/>
-          <p:cNvSpPr/>
-          <p:nvPr/>
-        </p:nvSpPr>
-        <p:spPr>
-          <a:xfrm>
-            <a:off x="7680959" y="2103120"/>
-            <a:ext cx="1874519" cy="1828800"/>
-          </a:xfrm>
-          <a:prstGeom prst="roundRect">
-            <a:avLst>
-              <a:gd name="adj" fmla="val 10000"/>
-            </a:avLst>
-          </a:prstGeom>
-          <a:solidFill>
-            <a:srgbClr val="FFFFFF"/>
-          </a:solidFill>
-          <a:ln w="15875">
-            <a:solidFill>
-              <a:srgbClr val="E2D7C2"/>
-            </a:solidFill>
-          </a:ln>
-        </p:spPr>
-        <p:style>
-          <a:lnRef idx="1">
-            <a:schemeClr val="accent1"/>
-          </a:lnRef>
-          <a:fillRef idx="3">
-            <a:schemeClr val="accent1"/>
-          </a:fillRef>
-          <a:effectRef idx="2">
-            <a:schemeClr val="accent1"/>
-          </a:effectRef>
-          <a:fontRef idx="minor">
-            <a:schemeClr val="lt1"/>
-          </a:fontRef>
-        </p:style>
-        <p:txBody>
-          <a:bodyPr rtlCol="0" anchor="ctr"/>
-          <a:lstStyle/>
-          <a:p>
-            <a:pPr algn="ctr"/>
-            <a:endParaRPr/>
-          </a:p>
-        </p:txBody>
-      </p:sp>
-      <p:sp>
-        <p:nvSpPr>
-          <p:cNvPr id="27" name="Rounded Rectangle 26"/>
-          <p:cNvSpPr/>
-          <p:nvPr/>
-        </p:nvSpPr>
-        <p:spPr>
-          <a:xfrm>
-            <a:off x="7680959" y="2103120"/>
-            <a:ext cx="1874519" cy="114300"/>
-          </a:xfrm>
-          <a:prstGeom prst="roundRect">
-            <a:avLst>
-              <a:gd name="adj" fmla="val 50000"/>
-            </a:avLst>
-          </a:prstGeom>
-          <a:solidFill>
-            <a:srgbClr val="A85A38"/>
-          </a:solidFill>
-          <a:ln>
-            <a:noFill/>
-          </a:ln>
-        </p:spPr>
-        <p:style>
-          <a:lnRef idx="1">
-            <a:schemeClr val="accent1"/>
-          </a:lnRef>
-          <a:fillRef idx="3">
-            <a:schemeClr val="accent1"/>
-          </a:fillRef>
-          <a:effectRef idx="2">
-            <a:schemeClr val="accent1"/>
-          </a:effectRef>
-          <a:fontRef idx="minor">
-            <a:schemeClr val="lt1"/>
-          </a:fontRef>
-        </p:style>
-        <p:txBody>
-          <a:bodyPr rtlCol="0" anchor="ctr"/>
-          <a:lstStyle/>
-          <a:p>
-            <a:pPr algn="ctr"/>
-            <a:endParaRPr/>
-          </a:p>
-        </p:txBody>
-      </p:sp>
-      <p:sp>
-        <p:nvSpPr>
-          <p:cNvPr id="28" name="TextBox 27"/>
-          <p:cNvSpPr txBox="1"/>
-          <p:nvPr/>
-        </p:nvSpPr>
-        <p:spPr>
-          <a:xfrm>
-            <a:off x="7818119" y="2286000"/>
-            <a:ext cx="1600199" cy="365760"/>
-          </a:xfrm>
-          <a:prstGeom prst="rect">
-            <a:avLst/>
-          </a:prstGeom>
-          <a:noFill/>
-        </p:spPr>
-        <p:txBody>
-          <a:bodyPr wrap="square" anchor="t">
-            <a:spAutoFit/>
-          </a:bodyPr>
-          <a:lstStyle/>
-          <a:p>
-            <a:pPr algn="ctr">
-              <a:spcBef>
-                <a:spcPts val="0"/>
-              </a:spcBef>
-              <a:spcAft>
-                <a:spcPts val="200"/>
-              </a:spcAft>
-            </a:pPr>
-            <a:r>
-              <a:rPr sz="1350" b="1">
-                <a:solidFill>
-                  <a:srgbClr val="A85A38"/>
-                </a:solidFill>
-                <a:latin typeface="Liberation Sans"/>
-              </a:rPr>
-              <a:t>MERGE</a:t>
-            </a:r>
-          </a:p>
-        </p:txBody>
-      </p:sp>
-      <p:sp>
-        <p:nvSpPr>
-          <p:cNvPr id="29" name="TextBox 28"/>
-          <p:cNvSpPr txBox="1"/>
-          <p:nvPr/>
-        </p:nvSpPr>
-        <p:spPr>
-          <a:xfrm>
-            <a:off x="7818119" y="2788920"/>
-            <a:ext cx="1600199" cy="914400"/>
-          </a:xfrm>
-          <a:prstGeom prst="rect">
-            <a:avLst/>
-          </a:prstGeom>
-          <a:noFill/>
-        </p:spPr>
-        <p:txBody>
-          <a:bodyPr wrap="square" anchor="t">
-            <a:spAutoFit/>
-          </a:bodyPr>
-          <a:lstStyle/>
-          <a:p>
-            <a:pPr algn="ctr">
-              <a:spcBef>
-                <a:spcPts val="0"/>
-              </a:spcBef>
-              <a:spcAft>
-                <a:spcPts val="200"/>
-              </a:spcAft>
-            </a:pPr>
-            <a:r>
-              <a:rPr sz="1250" b="0">
-                <a:solidFill>
-                  <a:srgbClr val="6E645B"/>
-                </a:solidFill>
-                <a:latin typeface="Liberation Sans"/>
-              </a:rPr>
-              <a:t>CTtransit GTFS
-stop + schedule join</a:t>
-            </a:r>
-          </a:p>
-        </p:txBody>
-      </p:sp>
-      <p:cxnSp>
-        <p:nvCxnSpPr>
-          <p:cNvPr id="30" name="Connector 29"/>
-          <p:cNvCxnSpPr/>
-          <p:nvPr/>
-        </p:nvCxnSpPr>
-        <p:spPr>
-          <a:xfrm>
-            <a:off x="9628632" y="3017520"/>
-            <a:ext cx="356616" cy="0"/>
-          </a:xfrm>
-          <a:prstGeom prst="line">
-            <a:avLst/>
-          </a:prstGeom>
-          <a:ln w="38100">
-            <a:solidFill>
-              <a:srgbClr val="A85A38"/>
-            </a:solidFill>
-          </a:ln>
-        </p:spPr>
-        <p:style>
-          <a:lnRef idx="2">
-            <a:schemeClr val="accent1"/>
-          </a:lnRef>
-          <a:fillRef idx="0">
-            <a:schemeClr val="accent1"/>
-          </a:fillRef>
-          <a:effectRef idx="1">
-            <a:schemeClr val="accent1"/>
-          </a:effectRef>
-          <a:fontRef idx="minor">
-            <a:schemeClr val="tx1"/>
-          </a:fontRef>
-        </p:style>
-      </p:cxnSp>
-      <p:sp>
-        <p:nvSpPr>
-          <p:cNvPr id="32" name="Rounded Rectangle 31"/>
-          <p:cNvSpPr/>
-          <p:nvPr/>
-        </p:nvSpPr>
-        <p:spPr>
-          <a:xfrm>
-            <a:off x="10058399" y="2103120"/>
-            <a:ext cx="1874519" cy="1828800"/>
-          </a:xfrm>
-          <a:prstGeom prst="roundRect">
-            <a:avLst>
-              <a:gd name="adj" fmla="val 10000"/>
-            </a:avLst>
-          </a:prstGeom>
-          <a:solidFill>
-            <a:srgbClr val="FFFFFF"/>
-          </a:solidFill>
-          <a:ln w="15875">
-            <a:solidFill>
-              <a:srgbClr val="E2D7C2"/>
-            </a:solidFill>
-          </a:ln>
-        </p:spPr>
-        <p:style>
-          <a:lnRef idx="1">
-            <a:schemeClr val="accent1"/>
-          </a:lnRef>
-          <a:fillRef idx="3">
-            <a:schemeClr val="accent1"/>
-          </a:fillRef>
-          <a:effectRef idx="2">
-            <a:schemeClr val="accent1"/>
-          </a:effectRef>
-          <a:fontRef idx="minor">
-            <a:schemeClr val="lt1"/>
-          </a:fontRef>
-        </p:style>
-        <p:txBody>
-          <a:bodyPr rtlCol="0" anchor="ctr"/>
-          <a:lstStyle/>
-          <a:p>
-            <a:pPr algn="ctr"/>
-            <a:endParaRPr/>
-          </a:p>
-        </p:txBody>
-      </p:sp>
-      <p:sp>
-        <p:nvSpPr>
-          <p:cNvPr id="33" name="Rounded Rectangle 32"/>
-          <p:cNvSpPr/>
-          <p:nvPr/>
-        </p:nvSpPr>
-        <p:spPr>
-          <a:xfrm>
-            <a:off x="10058399" y="2103120"/>
-            <a:ext cx="1874519" cy="114300"/>
-          </a:xfrm>
-          <a:prstGeom prst="roundRect">
-            <a:avLst>
-              <a:gd name="adj" fmla="val 50000"/>
-            </a:avLst>
-          </a:prstGeom>
-          <a:solidFill>
-            <a:srgbClr val="2E2A26"/>
-          </a:solidFill>
-          <a:ln>
-            <a:noFill/>
-          </a:ln>
-        </p:spPr>
-        <p:style>
-          <a:lnRef idx="1">
-            <a:schemeClr val="accent1"/>
-          </a:lnRef>
-          <a:fillRef idx="3">
-            <a:schemeClr val="accent1"/>
-          </a:fillRef>
-          <a:effectRef idx="2">
-            <a:schemeClr val="accent1"/>
-          </a:effectRef>
-          <a:fontRef idx="minor">
-            <a:schemeClr val="lt1"/>
-          </a:fontRef>
-        </p:style>
-        <p:txBody>
-          <a:bodyPr rtlCol="0" anchor="ctr"/>
-          <a:lstStyle/>
-          <a:p>
-            <a:pPr algn="ctr"/>
-            <a:endParaRPr/>
-          </a:p>
-        </p:txBody>
-      </p:sp>
-      <p:sp>
-        <p:nvSpPr>
-          <p:cNvPr id="34" name="TextBox 33"/>
-          <p:cNvSpPr txBox="1"/>
-          <p:nvPr/>
-        </p:nvSpPr>
-        <p:spPr>
-          <a:xfrm>
-            <a:off x="10195559" y="2286000"/>
-            <a:ext cx="1600199" cy="365760"/>
-          </a:xfrm>
-          <a:prstGeom prst="rect">
-            <a:avLst/>
-          </a:prstGeom>
-          <a:noFill/>
-        </p:spPr>
-        <p:txBody>
-          <a:bodyPr wrap="square" anchor="t">
-            <a:spAutoFit/>
-          </a:bodyPr>
-          <a:lstStyle/>
-          <a:p>
-            <a:pPr algn="ctr">
-              <a:spcBef>
-                <a:spcPts val="0"/>
-              </a:spcBef>
-              <a:spcAft>
-                <a:spcPts val="200"/>
-              </a:spcAft>
-            </a:pPr>
-            <a:r>
-              <a:rPr sz="1350" b="1">
-                <a:solidFill>
-                  <a:srgbClr val="2E2A26"/>
-                </a:solidFill>
-                <a:latin typeface="Liberation Sans"/>
-              </a:rPr>
-              <a:t>SERVE</a:t>
-            </a:r>
-          </a:p>
-        </p:txBody>
-      </p:sp>
-      <p:sp>
-        <p:nvSpPr>
-          <p:cNvPr id="35" name="TextBox 34"/>
-          <p:cNvSpPr txBox="1"/>
-          <p:nvPr/>
-        </p:nvSpPr>
-        <p:spPr>
-          <a:xfrm>
-            <a:off x="10195559" y="2788920"/>
-            <a:ext cx="1600199" cy="914400"/>
-          </a:xfrm>
-          <a:prstGeom prst="rect">
-            <a:avLst/>
-          </a:prstGeom>
-          <a:noFill/>
-        </p:spPr>
-        <p:txBody>
-          <a:bodyPr wrap="square" anchor="t">
-            <a:spAutoFit/>
-          </a:bodyPr>
-          <a:lstStyle/>
-          <a:p>
-            <a:pPr algn="ctr">
-              <a:spcBef>
-                <a:spcPts val="0"/>
-              </a:spcBef>
-              <a:spcAft>
-                <a:spcPts val="200"/>
-              </a:spcAft>
-            </a:pPr>
-            <a:r>
-              <a:rPr sz="1250" b="0">
-                <a:solidFill>
-                  <a:srgbClr val="6E645B"/>
-                </a:solidFill>
-                <a:latin typeface="Liberation Sans"/>
-              </a:rPr>
-              <a:t>Query flow:
-intent → rank → cards</a:t>
-            </a:r>
-          </a:p>
-        </p:txBody>
-      </p:sp>
-      <p:sp>
-        <p:nvSpPr>
-          <p:cNvPr id="36" name="TextBox 35"/>
-          <p:cNvSpPr txBox="1"/>
-          <p:nvPr/>
-        </p:nvSpPr>
-        <p:spPr>
-          <a:xfrm>
-            <a:off x="822960" y="4480560"/>
-            <a:ext cx="10515600" cy="864339"/>
-          </a:xfrm>
-          <a:prstGeom prst="rect">
-            <a:avLst/>
-          </a:prstGeom>
-          <a:noFill/>
-        </p:spPr>
-        <p:txBody>
-          <a:bodyPr wrap="square">
-            <a:spAutoFit/>
-          </a:bodyPr>
-          <a:lstStyle/>
-          <a:p>
-            <a:pPr>
-              <a:spcBef>
-                <a:spcPts val="0"/>
-              </a:spcBef>
-              <a:spcAft>
-                <a:spcPts val="800"/>
-              </a:spcAft>
-            </a:pPr>
-            <a:r>
-              <a:rPr sz="1450" dirty="0">
-                <a:solidFill>
-                  <a:srgbClr val="C96F4A"/>
-                </a:solidFill>
-                <a:latin typeface="Liberation Sans"/>
-              </a:rPr>
-              <a:t>•  </a:t>
-            </a:r>
-            <a:r>
-              <a:rPr sz="1450" b="1" dirty="0">
-                <a:solidFill>
-                  <a:srgbClr val="2E2A26"/>
-                </a:solidFill>
-                <a:latin typeface="Liberation Sans"/>
-              </a:rPr>
-              <a:t>Today (hackathon): </a:t>
-            </a:r>
-            <a:r>
-              <a:rPr sz="1450" b="0" dirty="0">
-                <a:solidFill>
-                  <a:srgbClr val="2E2A26"/>
-                </a:solidFill>
-                <a:latin typeface="Liberation Sans"/>
-              </a:rPr>
-              <a:t>hand-curated dataset, ~</a:t>
-            </a:r>
-            <a:r>
-              <a:rPr lang="en-US" sz="1450" dirty="0">
-                <a:solidFill>
-                  <a:srgbClr val="2E2A26"/>
-                </a:solidFill>
-                <a:latin typeface="Liberation Sans"/>
-              </a:rPr>
-              <a:t>15</a:t>
-            </a:r>
-            <a:r>
-              <a:rPr sz="1450" b="0" dirty="0">
-                <a:solidFill>
-                  <a:srgbClr val="2E2A26"/>
-                </a:solidFill>
-                <a:latin typeface="Liberation Sans"/>
-              </a:rPr>
-              <a:t> Greater Hartford sites — every row has name, address, type, and phone or hours. Demo runs client-side; nothing to fail at 5 PM.</a:t>
-            </a:r>
-          </a:p>
-          <a:p>
-            <a:pPr>
-              <a:spcBef>
-                <a:spcPts val="0"/>
-              </a:spcBef>
-              <a:spcAft>
-                <a:spcPts val="800"/>
-              </a:spcAft>
-            </a:pPr>
-            <a:r>
-              <a:rPr sz="1450" dirty="0">
-                <a:solidFill>
-                  <a:srgbClr val="C96F4A"/>
-                </a:solidFill>
-                <a:latin typeface="Liberation Sans"/>
-              </a:rPr>
-              <a:t>•  </a:t>
-            </a:r>
-            <a:r>
-              <a:rPr sz="1450" b="1" dirty="0">
-                <a:solidFill>
-                  <a:srgbClr val="2E2A26"/>
-                </a:solidFill>
-                <a:latin typeface="Liberation Sans"/>
-              </a:rPr>
-              <a:t>Next: </a:t>
-            </a:r>
-            <a:r>
-              <a:rPr sz="1450" b="0" dirty="0">
-                <a:solidFill>
-                  <a:srgbClr val="2E2A26"/>
-                </a:solidFill>
-                <a:latin typeface="Liberation Sans"/>
-              </a:rPr>
-              <a:t>hourly refresh job + 211 CT / Foodshare partnership for live hours; volunteer-reported updates as the freshness loop.</a:t>
-            </a:r>
-          </a:p>
-        </p:txBody>
-      </p:sp>
+        </p:spPr>
+      </p:pic>
     </p:spTree>
   </p:cSld>
   <p:clrMapOvr>

</xml_diff>